<commit_message>
docs: remove Zero Trust slides from Paper 2's companion deck
Matches the removal from paper/mantis_paper2.tex: drops the two Zero
Trust Backplane slides entirely, renumbers the remaining six slides (1-8
instead of 1-10), and updates the recap, evaluation-summary, and closing
slides to describe four extensions with 139 tests and one real defect
(the dispute-workflow scenario-prompt gap), with a brief factual note on
each of those slides that Zero Trust Backplane integration was explored
to the same standard but is being carried forward as a separate, dedicated
effort. The original MANTIS_Demo.pptx (Paper 1's deck) is untouched.

Verified: 8 slides generated, all shapes within slide bounds, text
density on every edited slide comparable to or lower than slides that
were already shipping correctly.

Co-Authored-By: Claude Sonnet 5 <noreply@anthropic.com>
</commit_message>
<xml_diff>
--- a/MANTIS_Demo_Extensions.pptx
+++ b/MANTIS_Demo_Extensions.pptx
@@ -13,8 +13,6 @@
     <p:sldId id="261" r:id="rId13"/>
     <p:sldId id="262" r:id="rId14"/>
     <p:sldId id="263" r:id="rId15"/>
-    <p:sldId id="264" r:id="rId16"/>
-    <p:sldId id="265" r:id="rId17"/>
   </p:sldIdLst>
   <p:sldSz cx="12191695" cy="6858000" type="screen4x3"/>
   <p:notesSz cx="6858000" cy="9144000"/>
@@ -548,88 +546,6 @@
 </p:notes>
 </file>
 
-<file path=ppt/notesSlides/notesSlide10.xml><?xml version="1.0" encoding="utf-8"?>
-<p:notes xmlns:a="http://schemas.openxmlformats.org/drawingml/2006/main" xmlns:p="http://schemas.openxmlformats.org/presentationml/2006/main" xmlns:r="http://schemas.openxmlformats.org/officeDocument/2006/relationships">
-  <p:cSld>
-    <p:spTree>
-      <p:nvGrpSpPr>
-        <p:cNvPr id="1" name=""/>
-        <p:cNvGrpSpPr/>
-        <p:nvPr/>
-      </p:nvGrpSpPr>
-      <p:grpSpPr>
-        <a:xfrm>
-          <a:off x="0" y="0"/>
-          <a:ext cx="0" cy="0"/>
-          <a:chOff x="0" y="0"/>
-          <a:chExt cx="0" cy="0"/>
-        </a:xfrm>
-      </p:grpSpPr>
-      <p:sp>
-        <p:nvSpPr>
-          <p:cNvPr id="2" name="Slide Image Placeholder 1"/>
-          <p:cNvSpPr>
-            <a:spLocks noGrp="1"/>
-          </p:cNvSpPr>
-          <p:nvPr>
-            <p:ph type="sldImg" idx="2"/>
-          </p:nvPr>
-        </p:nvSpPr>
-        <p:spPr/>
-      </p:sp>
-      <p:sp>
-        <p:nvSpPr>
-          <p:cNvPr id="3" name="Notes Placeholder 2"/>
-          <p:cNvSpPr>
-            <a:spLocks noGrp="1"/>
-          </p:cNvSpPr>
-          <p:nvPr>
-            <p:ph type="body" idx="3" sz="quarter"/>
-          </p:nvPr>
-        </p:nvSpPr>
-        <p:spPr/>
-        <p:txBody>
-          <a:bodyPr/>
-          <a:lstStyle/>
-          <a:p>
-            <a:r>
-              <a:t>That's MANTIS Extended.</a:t>
-            </a:r>
-          </a:p>
-          <a:p/>
-          <a:p>
-            <a:r>
-              <a:t>Closing message: the headline result of this second paper isn't any single extension -- it's that Paper 1's plugin and inventory interfaces held up completely unmodified across all five, including a defensive plugin, four separate telemetry backends, an integration surface for someone else's independent Zero Trust project verified with real repeated-trial statistics, a new banking process, and a UI.</a:t>
-            </a:r>
-          </a:p>
-          <a:p/>
-          <a:p>
-            <a:r>
-              <a:t>Everything shown today is reproducible from the checked-in configs in the repository, same as Paper 1. Thank you, and happy to take questions or walk through any extension live.</a:t>
-            </a:r>
-          </a:p>
-        </p:txBody>
-      </p:sp>
-      <p:sp>
-        <p:nvSpPr>
-          <p:cNvPr id="4" name="Slide Number Placeholder 3"/>
-          <p:cNvSpPr>
-            <a:spLocks noGrp="1"/>
-          </p:cNvSpPr>
-          <p:nvPr>
-            <p:ph type="sldNum" idx="5" sz="quarter"/>
-          </p:nvPr>
-        </p:nvSpPr>
-        <p:spPr/>
-      </p:sp>
-    </p:spTree>
-  </p:cSld>
-  <p:clrMapOvr>
-    <a:masterClrMapping/>
-  </p:clrMapOvr>
-</p:notes>
-</file>
-
 <file path=ppt/notesSlides/notesSlide2.xml><?xml version="1.0" encoding="utf-8"?>
 <p:notes xmlns:a="http://schemas.openxmlformats.org/drawingml/2006/main" xmlns:p="http://schemas.openxmlformats.org/presentationml/2006/main" xmlns:r="http://schemas.openxmlformats.org/officeDocument/2006/relationships">
   <p:cSld>
@@ -675,19 +591,19 @@
           <a:lstStyle/>
           <a:p>
             <a:r>
-              <a:t>All five items on this slide are quoted directly from Paper 1's own coding plan section 11, "Post-Paper Extensions" -- not a list we assembled after the fact.</a:t>
+              <a:t>All four items on this slide are quoted directly from Paper 1's own coding plan section 11, "Post-Paper Extensions" -- not a list we assembled after the fact. A fifth item on that same list, a Zero Trust Backplane integration, was also explored to the same live-verified standard, but is being carried forward as a separate, dedicated effort with a real independent Zero Trust Backplane project rather than reported as part of this deck's own evidence.</a:t>
             </a:r>
           </a:p>
           <a:p/>
           <a:p>
             <a:r>
-              <a:t>Walk the five briefly: more telemetry backends, defensive plugins through the same interface as attacks, a Zero Trust integration point, more banking processes, and a thin UI over the CLI.</a:t>
+              <a:t>Walk the four briefly: more telemetry backends, defensive plugins through the same interface as attacks, more banking processes, and a thin UI over the CLI.</a:t>
             </a:r>
           </a:p>
           <a:p/>
           <a:p>
             <a:r>
-              <a:t>Key point: each of the next five sections covers exactly one of these, in the same order, with live evidence for each.</a:t>
+              <a:t>Key point: each of the next four sections covers exactly one of these, in the same order, with live evidence for each.</a:t>
             </a:r>
           </a:p>
         </p:txBody>
@@ -933,25 +849,25 @@
           <a:lstStyle/>
           <a:p>
             <a:r>
-              <a:t>Third extension, and this one has a genuinely interesting story: while building this, we discovered a separate team has already built a substantially more complete Zero Trust Backplane against this exact same banking testbed.</a:t>
+              <a:t>Third extension: a genuinely new banking process, not a new prompt into an existing workflow -- filing and tracking a transaction dispute, as a third route under the front-office router.</a:t>
             </a:r>
           </a:p>
           <a:p/>
           <a:p>
             <a:r>
-              <a:t>Their project scans source code to discover agents and tools, mapping them onto canonical identities. MANTIS's own inventory already reports that same information live, since it's introspected from the running system -- so MANTIS's inventory is a natural substitute data source for their scanner, not a competing thing.</a:t>
+              <a:t>Worth distinguishing from something that already existed: the chatbot already answers "how do I dispute a transaction" as an FAQ. This is different -- it actually files a real case with a real generated ID, persisted in the same database the manual-review process already uses.</a:t>
             </a:r>
           </a:p>
           <a:p/>
           <a:p>
             <a:r>
-              <a:t>What we built on the MANTIS side is a representative slice -- a policy generator and an enforcement plugin -- kept entirely outside MANTIS's own code, self-registering only when explicitly imported. MANTIS never depends on it existing, which was the whole design constraint Paper 1 set for this extension point.</a:t>
+              <a:t>The honest part of this story: the first version produced zero tool calls across three consecutive live trials, with correct routing every time. The cause wasn't a code defect -- it was that our scenario prompt never stated a customer id, which the tool needs, and which every other scenario in this codebase states explicitly. We fixed the prompt, not the tool, and the very next live run filed a real case correctly.</a:t>
             </a:r>
           </a:p>
           <a:p/>
           <a:p>
             <a:r>
-              <a:t>Next slide has the finding this work surfaced along the way.</a:t>
+              <a:t>Key point: a clean exit and correct routing both looked fine; only checking the actual tool-call events revealed nothing had happened.</a:t>
             </a:r>
           </a:p>
         </p:txBody>
@@ -1021,25 +937,25 @@
           <a:lstStyle/>
           <a:p>
             <a:r>
-              <a:t>This is the finding: building a default-deny-by-domain policy only works if domains actually report different tools. Paper 1's own inventory interface didn't do that -- every domain reported the entire merged tool list, which would have made this whole extension meaningless.</a:t>
+              <a:t>Final extension: the minimal UI Paper 1's coding plan named last -- a schema-driven editor and trace viewer, explicitly constrained to invoke the same CLI, not implement a second version of anything.</a:t>
             </a:r>
           </a:p>
           <a:p/>
           <a:p>
             <a:r>
-              <a:t>The fix was real and precise: tools are genuinely domain-tagged, through which source module a domain's agents import from. We corrected the inventory and added a regression test proving a back-office-only tool is unreachable from front or mid office's reported tools.</a:t>
+              <a:t>The dropdowns for domain, workflow, scenario, and plugin are populated live from the same registries the CLI itself reads from -- not a hardcoded list baked into the page that could quietly drift from the real system.</a:t>
             </a:r>
           </a:p>
           <a:p/>
           <a:p>
             <a:r>
-              <a:t>We didn't stop at one clean run, though. Revisiting this extension specifically to replace a single-run anecdote with real statistics: we ran the real plugin against all 770 (agent, tool) pairs the live inventory implies -- every combination the system actually has -- and it enforced every single one correctly. Then five live trials against a real model, zero false-positive denials in any of them.</a:t>
+              <a:t>Key point, and we verified this directly rather than assuming it from the code structure: submitted a configuration with a deliberately invalid domain through the UI, and got back the real CLI's own "Unknown domain" error text -- because it's the same subprocess, not a UI-side reimplementation of that check.</a:t>
             </a:r>
           </a:p>
           <a:p/>
           <a:p>
             <a:r>
-              <a:t>Building that harness surfaced a second real bug, the same shape as one we'd already fixed for the guardrail extension: this plugin's own denials were being silently recorded as an attack, not a defense, in the trace. Fixed, with a test that exercises the real hook bus end to end so it can't come back silently.</a:t>
+              <a:t>We also confirmed it as a real running server, not just passing an internal test client -- launched it for real and queried it over HTTP, and it correctly reported the live system: 32 agents, 22 tools, 27 existing run artifacts, at the time we checked.</a:t>
             </a:r>
           </a:p>
         </p:txBody>
@@ -1109,25 +1025,19 @@
           <a:lstStyle/>
           <a:p>
             <a:r>
-              <a:t>Fourth extension: a genuinely new banking process, not a new prompt into an existing workflow -- filing and tracking a transaction dispute, as a third route under the front-office router.</a:t>
+              <a:t>Summary slide -- every extension checked against real data or a real live run, the same standard Paper 1 set for itself.</a:t>
             </a:r>
           </a:p>
           <a:p/>
           <a:p>
             <a:r>
-              <a:t>Worth distinguishing from something that already existed: the chatbot already answers "how do I dispute a transaction" as an FAQ. This is different -- it actually files a real case with a real generated ID, persisted in the same database the manual-review process already uses.</a:t>
+              <a:t>The offline suite stands at 139 tests -- covering all four extensions, including the three additional exporters added in this revision -- all still running in under a minute with no live model key required.</a:t>
             </a:r>
           </a:p>
           <a:p/>
           <a:p>
             <a:r>
-              <a:t>The honest part of this story: the first version produced zero tool calls across three consecutive live trials, with correct routing every time. The cause wasn't a code defect -- it was that our scenario prompt never stated a customer id, which the tool needs, and which every other scenario in this codebase states explicitly. We fixed the prompt, not the tool, and the very next live run filed a real case correctly.</a:t>
-            </a:r>
-          </a:p>
-          <a:p/>
-          <a:p>
-            <a:r>
-              <a:t>Key point: this is the same lesson as the Zero Trust finding -- a clean exit and correct routing both looked fine; only checking the actual tool-call events revealed nothing had happened.</a:t>
+              <a:t>The three numbers at the bottom are the ones worth pausing on: zero changes required to any of MANTIS's core interfaces to add any of these four extensions -- the plugin and inventory interfaces held up exactly as designed. And one real defect found and fixed along the way, invisible from a clean process exit -- a scenario-prompt gap in the dispute workflow found only by checking the actual tool-call events.</a:t>
             </a:r>
           </a:p>
         </p:txBody>
@@ -1197,107 +1107,19 @@
           <a:lstStyle/>
           <a:p>
             <a:r>
-              <a:t>Final extension: the minimal UI Paper 1's coding plan named last -- a schema-driven editor and trace viewer, explicitly constrained to invoke the same CLI, not implement a second version of anything.</a:t>
+              <a:t>That's MANTIS Extended.</a:t>
             </a:r>
           </a:p>
           <a:p/>
           <a:p>
             <a:r>
-              <a:t>The dropdowns for domain, workflow, scenario, and plugin are populated live from the same registries the CLI itself reads from -- not a hardcoded list baked into the page that could quietly drift from the real system.</a:t>
+              <a:t>Closing message: the headline result of this second paper isn't any single extension -- it's that Paper 1's plugin and inventory interfaces held up completely unmodified across all four, including a defensive plugin, four separate telemetry backends, a new banking process, and a UI. A fifth item, Zero Trust Backplane integration, was explored to the same standard and is being carried forward as its own dedicated effort with a real independent project, separate from this repository.</a:t>
             </a:r>
           </a:p>
           <a:p/>
           <a:p>
             <a:r>
-              <a:t>Key point, and we verified this directly rather than assuming it from the code structure: submitted a configuration with a deliberately invalid domain through the UI, and got back the real CLI's own "Unknown domain" error text -- because it's the same subprocess, not a UI-side reimplementation of that check.</a:t>
-            </a:r>
-          </a:p>
-          <a:p/>
-          <a:p>
-            <a:r>
-              <a:t>We also confirmed it as a real running server, not just passing an internal test client -- launched it for real and queried it over HTTP, and it correctly reported the live system: 32 agents, 22 tools, 27 existing run artifacts, at the time we checked.</a:t>
-            </a:r>
-          </a:p>
-        </p:txBody>
-      </p:sp>
-      <p:sp>
-        <p:nvSpPr>
-          <p:cNvPr id="4" name="Slide Number Placeholder 3"/>
-          <p:cNvSpPr>
-            <a:spLocks noGrp="1"/>
-          </p:cNvSpPr>
-          <p:nvPr>
-            <p:ph type="sldNum" idx="5" sz="quarter"/>
-          </p:nvPr>
-        </p:nvSpPr>
-        <p:spPr/>
-      </p:sp>
-    </p:spTree>
-  </p:cSld>
-  <p:clrMapOvr>
-    <a:masterClrMapping/>
-  </p:clrMapOvr>
-</p:notes>
-</file>
-
-<file path=ppt/notesSlides/notesSlide9.xml><?xml version="1.0" encoding="utf-8"?>
-<p:notes xmlns:a="http://schemas.openxmlformats.org/drawingml/2006/main" xmlns:p="http://schemas.openxmlformats.org/presentationml/2006/main" xmlns:r="http://schemas.openxmlformats.org/officeDocument/2006/relationships">
-  <p:cSld>
-    <p:spTree>
-      <p:nvGrpSpPr>
-        <p:cNvPr id="1" name=""/>
-        <p:cNvGrpSpPr/>
-        <p:nvPr/>
-      </p:nvGrpSpPr>
-      <p:grpSpPr>
-        <a:xfrm>
-          <a:off x="0" y="0"/>
-          <a:ext cx="0" cy="0"/>
-          <a:chOff x="0" y="0"/>
-          <a:chExt cx="0" cy="0"/>
-        </a:xfrm>
-      </p:grpSpPr>
-      <p:sp>
-        <p:nvSpPr>
-          <p:cNvPr id="2" name="Slide Image Placeholder 1"/>
-          <p:cNvSpPr>
-            <a:spLocks noGrp="1"/>
-          </p:cNvSpPr>
-          <p:nvPr>
-            <p:ph type="sldImg" idx="2"/>
-          </p:nvPr>
-        </p:nvSpPr>
-        <p:spPr/>
-      </p:sp>
-      <p:sp>
-        <p:nvSpPr>
-          <p:cNvPr id="3" name="Notes Placeholder 2"/>
-          <p:cNvSpPr>
-            <a:spLocks noGrp="1"/>
-          </p:cNvSpPr>
-          <p:nvPr>
-            <p:ph type="body" idx="3" sz="quarter"/>
-          </p:nvPr>
-        </p:nvSpPr>
-        <p:spPr/>
-        <p:txBody>
-          <a:bodyPr/>
-          <a:lstStyle/>
-          <a:p>
-            <a:r>
-              <a:t>Summary slide -- every extension checked against real data or a real live run, the same standard Paper 1 set for itself.</a:t>
-            </a:r>
-          </a:p>
-          <a:p/>
-          <a:p>
-            <a:r>
-              <a:t>The offline suite stands at 147 tests -- covering all five extensions, including the three additional exporters and the deeper Zero Trust evidence added in a second pass -- all still running in under a minute with no live model key required.</a:t>
-            </a:r>
-          </a:p>
-          <a:p/>
-          <a:p>
-            <a:r>
-              <a:t>The three numbers at the bottom are the ones worth pausing on: zero changes required to any of MANTIS's core interfaces to add any of these five extensions -- the plugin and inventory interfaces held up exactly as designed. And three real defects found and fixed along the way, none visible from a clean process exit -- a domain-scoping bug, a scenario-prompt gap, and an event-misclassification bug in the Zero Trust plugin found only when we went back to replace a single-run anecdote with real repeated-trial statistics.</a:t>
+              <a:t>Everything shown today is reproducible from the checked-in configs in the repository, same as Paper 1. Thank you, and happy to take questions or walk through any extension live.</a:t>
             </a:r>
           </a:p>
         </p:txBody>
@@ -4770,506 +4592,6 @@
 </p:sld>
 </file>
 
-<file path=ppt/slides/slide10.xml><?xml version="1.0" encoding="utf-8"?>
-<p:sld xmlns:a="http://schemas.openxmlformats.org/drawingml/2006/main" xmlns:p="http://schemas.openxmlformats.org/presentationml/2006/main" xmlns:r="http://schemas.openxmlformats.org/officeDocument/2006/relationships">
-  <p:cSld>
-    <p:spTree>
-      <p:nvGrpSpPr>
-        <p:cNvPr id="1" name=""/>
-        <p:cNvGrpSpPr/>
-        <p:nvPr/>
-      </p:nvGrpSpPr>
-      <p:grpSpPr/>
-      <p:sp>
-        <p:nvSpPr>
-          <p:cNvPr id="2" name="Rectangle 1"/>
-          <p:cNvSpPr/>
-          <p:nvPr/>
-        </p:nvSpPr>
-        <p:spPr>
-          <a:xfrm>
-            <a:off x="0" y="0"/>
-            <a:ext cx="12191695" cy="6858000"/>
-          </a:xfrm>
-          <a:prstGeom prst="rect">
-            <a:avLst/>
-          </a:prstGeom>
-          <a:solidFill>
-            <a:srgbClr val="071022"/>
-          </a:solidFill>
-          <a:ln>
-            <a:noFill/>
-          </a:ln>
-          <a:effectLst/>
-        </p:spPr>
-        <p:style>
-          <a:lnRef idx="1">
-            <a:schemeClr val="accent1"/>
-          </a:lnRef>
-          <a:fillRef idx="3">
-            <a:schemeClr val="accent1"/>
-          </a:fillRef>
-          <a:effectRef idx="2">
-            <a:schemeClr val="accent1"/>
-          </a:effectRef>
-          <a:fontRef idx="minor">
-            <a:schemeClr val="lt1"/>
-          </a:fontRef>
-        </p:style>
-        <p:txBody>
-          <a:bodyPr rtlCol="0" anchor="ctr"/>
-          <a:lstStyle/>
-          <a:p>
-            <a:pPr algn="ctr"/>
-          </a:p>
-        </p:txBody>
-      </p:sp>
-      <p:sp>
-        <p:nvSpPr>
-          <p:cNvPr id="3" name="Rounded Rectangle 2"/>
-          <p:cNvSpPr/>
-          <p:nvPr/>
-        </p:nvSpPr>
-        <p:spPr>
-          <a:xfrm>
-            <a:off x="566928" y="292608"/>
-            <a:ext cx="310896" cy="310896"/>
-          </a:xfrm>
-          <a:prstGeom prst="roundRect">
-            <a:avLst>
-              <a:gd name="adj" fmla="val 16000"/>
-            </a:avLst>
-          </a:prstGeom>
-          <a:solidFill>
-            <a:srgbClr val="071022"/>
-          </a:solidFill>
-          <a:ln w="15875">
-            <a:solidFill>
-              <a:srgbClr val="EEF2F8"/>
-            </a:solidFill>
-          </a:ln>
-          <a:effectLst/>
-        </p:spPr>
-        <p:style>
-          <a:lnRef idx="1">
-            <a:schemeClr val="accent1"/>
-          </a:lnRef>
-          <a:fillRef idx="3">
-            <a:schemeClr val="accent1"/>
-          </a:fillRef>
-          <a:effectRef idx="2">
-            <a:schemeClr val="accent1"/>
-          </a:effectRef>
-          <a:fontRef idx="minor">
-            <a:schemeClr val="lt1"/>
-          </a:fontRef>
-        </p:style>
-        <p:txBody>
-          <a:bodyPr rtlCol="0" anchor="ctr" lIns="0" rIns="0" tIns="0" bIns="0"/>
-          <a:lstStyle/>
-          <a:p>
-            <a:pPr algn="ctr"/>
-            <a:r>
-              <a:rPr sz="1200" b="1">
-                <a:solidFill>
-                  <a:srgbClr val="EEF2F8"/>
-                </a:solidFill>
-                <a:latin typeface="Arial"/>
-              </a:rPr>
-              <a:t>UF</a:t>
-            </a:r>
-          </a:p>
-        </p:txBody>
-      </p:sp>
-      <p:sp>
-        <p:nvSpPr>
-          <p:cNvPr id="4" name="TextBox 3"/>
-          <p:cNvSpPr txBox="1"/>
-          <p:nvPr/>
-        </p:nvSpPr>
-        <p:spPr>
-          <a:xfrm>
-            <a:off x="969264" y="256032"/>
-            <a:ext cx="3291840" cy="384048"/>
-          </a:xfrm>
-          <a:prstGeom prst="rect">
-            <a:avLst/>
-          </a:prstGeom>
-          <a:noFill/>
-        </p:spPr>
-        <p:txBody>
-          <a:bodyPr wrap="square" anchor="t" lIns="0" rIns="0" tIns="0" bIns="0">
-            <a:spAutoFit/>
-          </a:bodyPr>
-          <a:lstStyle/>
-          <a:p>
-            <a:pPr algn="l">
-              <a:lnSpc>
-                <a:spcPct val="100000"/>
-              </a:lnSpc>
-              <a:spcAft>
-                <a:spcPts val="0"/>
-              </a:spcAft>
-            </a:pPr>
-            <a:r>
-              <a:rPr sz="1050" b="1" i="0">
-                <a:solidFill>
-                  <a:srgbClr val="EEF2F8"/>
-                </a:solidFill>
-                <a:latin typeface="Arial"/>
-              </a:rPr>
-              <a:t>Herbert Wertheim</a:t>
-            </a:r>
-          </a:p>
-          <a:p>
-            <a:pPr algn="l">
-              <a:lnSpc>
-                <a:spcPct val="100000"/>
-              </a:lnSpc>
-              <a:spcAft>
-                <a:spcPts val="0"/>
-              </a:spcAft>
-            </a:pPr>
-            <a:r>
-              <a:rPr sz="900" b="0" i="1">
-                <a:solidFill>
-                  <a:srgbClr val="AEBBD2"/>
-                </a:solidFill>
-                <a:latin typeface="Georgia"/>
-              </a:rPr>
-              <a:t>College of Engineering</a:t>
-            </a:r>
-          </a:p>
-        </p:txBody>
-      </p:sp>
-      <p:sp>
-        <p:nvSpPr>
-          <p:cNvPr id="5" name="TextBox 4"/>
-          <p:cNvSpPr txBox="1"/>
-          <p:nvPr/>
-        </p:nvSpPr>
-        <p:spPr>
-          <a:xfrm>
-            <a:off x="566928" y="896112"/>
-            <a:ext cx="8229600" cy="274320"/>
-          </a:xfrm>
-          <a:prstGeom prst="rect">
-            <a:avLst/>
-          </a:prstGeom>
-          <a:noFill/>
-        </p:spPr>
-        <p:txBody>
-          <a:bodyPr wrap="square" anchor="t" lIns="0" rIns="0" tIns="0" bIns="0">
-            <a:spAutoFit/>
-          </a:bodyPr>
-          <a:lstStyle/>
-          <a:p>
-            <a:pPr algn="l">
-              <a:lnSpc>
-                <a:spcPct val="115000"/>
-              </a:lnSpc>
-            </a:pPr>
-            <a:r>
-              <a:rPr sz="1100" b="1" i="0">
-                <a:solidFill>
-                  <a:srgbClr val="FF8A5C"/>
-                </a:solidFill>
-                <a:latin typeface="Consolas"/>
-              </a:rPr>
-              <a:t>THANK YOU</a:t>
-            </a:r>
-          </a:p>
-        </p:txBody>
-      </p:sp>
-      <p:sp>
-        <p:nvSpPr>
-          <p:cNvPr id="6" name="TextBox 5"/>
-          <p:cNvSpPr txBox="1"/>
-          <p:nvPr/>
-        </p:nvSpPr>
-        <p:spPr>
-          <a:xfrm>
-            <a:off x="566928" y="2788920"/>
-            <a:ext cx="10607040" cy="1188720"/>
-          </a:xfrm>
-          <a:prstGeom prst="rect">
-            <a:avLst/>
-          </a:prstGeom>
-          <a:noFill/>
-        </p:spPr>
-        <p:txBody>
-          <a:bodyPr wrap="square" anchor="t" lIns="0" rIns="0" tIns="0" bIns="0">
-            <a:spAutoFit/>
-          </a:bodyPr>
-          <a:lstStyle/>
-          <a:p>
-            <a:pPr algn="l">
-              <a:lnSpc>
-                <a:spcPct val="104000"/>
-              </a:lnSpc>
-            </a:pPr>
-            <a:r>
-              <a:rPr sz="2600" b="1" i="0">
-                <a:solidFill>
-                  <a:srgbClr val="EEF2F8"/>
-                </a:solidFill>
-                <a:latin typeface="Arial Black"/>
-              </a:rPr>
-              <a:t>Five extensions, zero core changes, real evidence for each</a:t>
-            </a:r>
-          </a:p>
-        </p:txBody>
-      </p:sp>
-      <p:sp>
-        <p:nvSpPr>
-          <p:cNvPr id="7" name="TextBox 6"/>
-          <p:cNvSpPr txBox="1"/>
-          <p:nvPr/>
-        </p:nvSpPr>
-        <p:spPr>
-          <a:xfrm>
-            <a:off x="566928" y="3611880"/>
-            <a:ext cx="9144000" cy="822960"/>
-          </a:xfrm>
-          <a:prstGeom prst="rect">
-            <a:avLst/>
-          </a:prstGeom>
-          <a:noFill/>
-        </p:spPr>
-        <p:txBody>
-          <a:bodyPr wrap="square" anchor="t" lIns="0" rIns="0" tIns="0" bIns="0">
-            <a:spAutoFit/>
-          </a:bodyPr>
-          <a:lstStyle/>
-          <a:p>
-            <a:pPr algn="l">
-              <a:lnSpc>
-                <a:spcPct val="130000"/>
-              </a:lnSpc>
-            </a:pPr>
-            <a:r>
-              <a:rPr sz="1400" b="0" i="1">
-                <a:solidFill>
-                  <a:srgbClr val="AEBBD2"/>
-                </a:solidFill>
-                <a:latin typeface="Georgia"/>
-              </a:rPr>
-              <a:t>Paper 1's interfaces held up exactly as designed. Happy to walk through any extension live,</a:t>
-            </a:r>
-          </a:p>
-          <a:p>
-            <a:pPr algn="l">
-              <a:lnSpc>
-                <a:spcPct val="130000"/>
-              </a:lnSpc>
-            </a:pPr>
-            <a:r>
-              <a:rPr sz="1400" b="0" i="1">
-                <a:solidFill>
-                  <a:srgbClr val="AEBBD2"/>
-                </a:solidFill>
-                <a:latin typeface="Georgia"/>
-              </a:rPr>
-              <a:t>or discuss where a production Zero Trust integration goes next.</a:t>
-            </a:r>
-          </a:p>
-        </p:txBody>
-      </p:sp>
-      <p:sp>
-        <p:nvSpPr>
-          <p:cNvPr id="8" name="TextBox 7"/>
-          <p:cNvSpPr txBox="1"/>
-          <p:nvPr/>
-        </p:nvSpPr>
-        <p:spPr>
-          <a:xfrm>
-            <a:off x="566928" y="4526280"/>
-            <a:ext cx="7315200" cy="457200"/>
-          </a:xfrm>
-          <a:prstGeom prst="rect">
-            <a:avLst/>
-          </a:prstGeom>
-          <a:noFill/>
-        </p:spPr>
-        <p:txBody>
-          <a:bodyPr wrap="square" anchor="t" lIns="0" rIns="0" tIns="0" bIns="0">
-            <a:spAutoFit/>
-          </a:bodyPr>
-          <a:lstStyle/>
-          <a:p>
-            <a:pPr algn="l">
-              <a:lnSpc>
-                <a:spcPct val="115000"/>
-              </a:lnSpc>
-            </a:pPr>
-            <a:r>
-              <a:rPr sz="1500" b="0" i="0">
-                <a:solidFill>
-                  <a:srgbClr val="AEBBD2"/>
-                </a:solidFill>
-                <a:latin typeface="Consolas"/>
-              </a:rPr>
-              <a:t>github.com/smartsystemslab-uf/MANTIS</a:t>
-            </a:r>
-          </a:p>
-        </p:txBody>
-      </p:sp>
-      <p:cxnSp>
-        <p:nvCxnSpPr>
-          <p:cNvPr id="9" name="Connector 8"/>
-          <p:cNvCxnSpPr/>
-          <p:nvPr/>
-        </p:nvCxnSpPr>
-        <p:spPr>
-          <a:xfrm>
-            <a:off x="566928" y="6382512"/>
-            <a:ext cx="2377440" cy="0"/>
-          </a:xfrm>
-          <a:prstGeom prst="line">
-            <a:avLst/>
-          </a:prstGeom>
-          <a:ln w="9525">
-            <a:solidFill>
-              <a:srgbClr val="7E8FAE"/>
-            </a:solidFill>
-          </a:ln>
-        </p:spPr>
-        <p:style>
-          <a:lnRef idx="2">
-            <a:schemeClr val="accent1"/>
-          </a:lnRef>
-          <a:fillRef idx="0">
-            <a:schemeClr val="accent1"/>
-          </a:fillRef>
-          <a:effectRef idx="1">
-            <a:schemeClr val="accent1"/>
-          </a:effectRef>
-          <a:fontRef idx="minor">
-            <a:schemeClr val="tx1"/>
-          </a:fontRef>
-        </p:style>
-      </p:cxnSp>
-      <p:cxnSp>
-        <p:nvCxnSpPr>
-          <p:cNvPr id="10" name="Connector 9"/>
-          <p:cNvCxnSpPr/>
-          <p:nvPr/>
-        </p:nvCxnSpPr>
-        <p:spPr>
-          <a:xfrm>
-            <a:off x="9326880" y="6382512"/>
-            <a:ext cx="2286000" cy="0"/>
-          </a:xfrm>
-          <a:prstGeom prst="line">
-            <a:avLst/>
-          </a:prstGeom>
-          <a:ln w="9525">
-            <a:solidFill>
-              <a:srgbClr val="7E8FAE"/>
-            </a:solidFill>
-          </a:ln>
-        </p:spPr>
-        <p:style>
-          <a:lnRef idx="2">
-            <a:schemeClr val="accent1"/>
-          </a:lnRef>
-          <a:fillRef idx="0">
-            <a:schemeClr val="accent1"/>
-          </a:fillRef>
-          <a:effectRef idx="1">
-            <a:schemeClr val="accent1"/>
-          </a:effectRef>
-          <a:fontRef idx="minor">
-            <a:schemeClr val="tx1"/>
-          </a:fontRef>
-        </p:style>
-      </p:cxnSp>
-      <p:sp>
-        <p:nvSpPr>
-          <p:cNvPr id="11" name="TextBox 10"/>
-          <p:cNvSpPr txBox="1"/>
-          <p:nvPr/>
-        </p:nvSpPr>
-        <p:spPr>
-          <a:xfrm>
-            <a:off x="3017520" y="6281928"/>
-            <a:ext cx="6217920" cy="256032"/>
-          </a:xfrm>
-          <a:prstGeom prst="rect">
-            <a:avLst/>
-          </a:prstGeom>
-          <a:noFill/>
-        </p:spPr>
-        <p:txBody>
-          <a:bodyPr wrap="square" anchor="t" lIns="0" rIns="0" tIns="0" bIns="0">
-            <a:spAutoFit/>
-          </a:bodyPr>
-          <a:lstStyle/>
-          <a:p>
-            <a:pPr algn="ctr">
-              <a:lnSpc>
-                <a:spcPct val="115000"/>
-              </a:lnSpc>
-            </a:pPr>
-            <a:r>
-              <a:rPr sz="800" b="0" i="0">
-                <a:solidFill>
-                  <a:srgbClr val="7E8FAE"/>
-                </a:solidFill>
-                <a:latin typeface="Consolas"/>
-              </a:rPr>
-              <a:t>Leading the Charge, Charging Ahead</a:t>
-            </a:r>
-          </a:p>
-        </p:txBody>
-      </p:sp>
-      <p:sp>
-        <p:nvSpPr>
-          <p:cNvPr id="12" name="TextBox 11"/>
-          <p:cNvSpPr txBox="1"/>
-          <p:nvPr/>
-        </p:nvSpPr>
-        <p:spPr>
-          <a:xfrm>
-            <a:off x="11430000" y="6281928"/>
-            <a:ext cx="548640" cy="256032"/>
-          </a:xfrm>
-          <a:prstGeom prst="rect">
-            <a:avLst/>
-          </a:prstGeom>
-          <a:noFill/>
-        </p:spPr>
-        <p:txBody>
-          <a:bodyPr wrap="square" anchor="t" lIns="0" rIns="0" tIns="0" bIns="0">
-            <a:spAutoFit/>
-          </a:bodyPr>
-          <a:lstStyle/>
-          <a:p>
-            <a:pPr algn="r">
-              <a:lnSpc>
-                <a:spcPct val="115000"/>
-              </a:lnSpc>
-            </a:pPr>
-            <a:r>
-              <a:rPr sz="900" b="1" i="0">
-                <a:solidFill>
-                  <a:srgbClr val="AEBBD2"/>
-                </a:solidFill>
-                <a:latin typeface="Consolas"/>
-              </a:rPr>
-              <a:t>10</a:t>
-            </a:r>
-          </a:p>
-        </p:txBody>
-      </p:sp>
-    </p:spTree>
-  </p:cSld>
-  <p:clrMapOvr>
-    <a:masterClrMapping/>
-  </p:clrMapOvr>
-</p:sld>
-</file>
-
 <file path=ppt/slides/slide2.xml><?xml version="1.0" encoding="utf-8"?>
 <p:sld xmlns:a="http://schemas.openxmlformats.org/drawingml/2006/main" xmlns:p="http://schemas.openxmlformats.org/presentationml/2006/main" xmlns:r="http://schemas.openxmlformats.org/officeDocument/2006/relationships">
   <p:cSld>
@@ -5515,7 +4837,7 @@
                 </a:solidFill>
                 <a:latin typeface="Arial Black"/>
               </a:rPr>
-              <a:t>Five extensions, named and deferred on purpose</a:t>
+              <a:t>Four extensions, named and deferred on purpose</a:t>
             </a:r>
           </a:p>
         </p:txBody>
@@ -5568,7 +4890,7 @@
         <p:spPr>
           <a:xfrm>
             <a:off x="566928" y="2286000"/>
-            <a:ext cx="2121408" cy="3566160"/>
+            <a:ext cx="2606040" cy="3566160"/>
           </a:xfrm>
           <a:prstGeom prst="roundRect">
             <a:avLst>
@@ -5616,7 +4938,7 @@
         <p:spPr>
           <a:xfrm>
             <a:off x="731520" y="2404872"/>
-            <a:ext cx="1792224" cy="274320"/>
+            <a:ext cx="2276856" cy="274320"/>
           </a:xfrm>
           <a:prstGeom prst="rect">
             <a:avLst/>
@@ -5655,7 +4977,7 @@
         <p:spPr>
           <a:xfrm>
             <a:off x="731520" y="2724912"/>
-            <a:ext cx="1792224" cy="3017520"/>
+            <a:ext cx="2276856" cy="3017520"/>
           </a:xfrm>
           <a:prstGeom prst="rect">
             <a:avLst/>
@@ -5674,7 +4996,7 @@
               </a:lnSpc>
             </a:pPr>
             <a:r>
-              <a:rPr sz="1000" b="0" i="0">
+              <a:rPr sz="1050" b="0" i="0">
                 <a:solidFill>
                   <a:srgbClr val="AEBBD2"/>
                 </a:solidFill>
@@ -5693,8 +5015,8 @@
         </p:nvSpPr>
         <p:spPr>
           <a:xfrm>
-            <a:off x="2779776" y="2286000"/>
-            <a:ext cx="2121408" cy="3566160"/>
+            <a:off x="3310128" y="2286000"/>
+            <a:ext cx="2606040" cy="3566160"/>
           </a:xfrm>
           <a:prstGeom prst="roundRect">
             <a:avLst>
@@ -5741,8 +5063,8 @@
         </p:nvSpPr>
         <p:spPr>
           <a:xfrm>
-            <a:off x="2944368" y="2404872"/>
-            <a:ext cx="1792224" cy="274320"/>
+            <a:off x="3474720" y="2404872"/>
+            <a:ext cx="2276856" cy="274320"/>
           </a:xfrm>
           <a:prstGeom prst="rect">
             <a:avLst/>
@@ -5780,8 +5102,8 @@
         </p:nvSpPr>
         <p:spPr>
           <a:xfrm>
-            <a:off x="2944368" y="2724912"/>
-            <a:ext cx="1792224" cy="3017520"/>
+            <a:off x="3474720" y="2724912"/>
+            <a:ext cx="2276856" cy="3017520"/>
           </a:xfrm>
           <a:prstGeom prst="rect">
             <a:avLst/>
@@ -5800,7 +5122,7 @@
               </a:lnSpc>
             </a:pPr>
             <a:r>
-              <a:rPr sz="1000" b="0" i="0">
+              <a:rPr sz="1050" b="0" i="0">
                 <a:solidFill>
                   <a:srgbClr val="AEBBD2"/>
                 </a:solidFill>
@@ -5819,8 +5141,8 @@
         </p:nvSpPr>
         <p:spPr>
           <a:xfrm>
-            <a:off x="4992624" y="2286000"/>
-            <a:ext cx="2121408" cy="3566160"/>
+            <a:off x="6053328" y="2286000"/>
+            <a:ext cx="2606040" cy="3566160"/>
           </a:xfrm>
           <a:prstGeom prst="roundRect">
             <a:avLst>
@@ -5867,8 +5189,8 @@
         </p:nvSpPr>
         <p:spPr>
           <a:xfrm>
-            <a:off x="5157216" y="2404872"/>
-            <a:ext cx="1792224" cy="274320"/>
+            <a:off x="6217920" y="2404872"/>
+            <a:ext cx="2276856" cy="274320"/>
           </a:xfrm>
           <a:prstGeom prst="rect">
             <a:avLst/>
@@ -5893,7 +5215,7 @@
                 </a:solidFill>
                 <a:latin typeface="Arial"/>
               </a:rPr>
-              <a:t>Zero Trust Backplane</a:t>
+              <a:t>Additional banking workloads</a:t>
             </a:r>
           </a:p>
         </p:txBody>
@@ -5906,8 +5228,8 @@
         </p:nvSpPr>
         <p:spPr>
           <a:xfrm>
-            <a:off x="5157216" y="2724912"/>
-            <a:ext cx="1792224" cy="3017520"/>
+            <a:off x="6217920" y="2724912"/>
+            <a:ext cx="2276856" cy="3017520"/>
           </a:xfrm>
           <a:prstGeom prst="rect">
             <a:avLst/>
@@ -5926,13 +5248,13 @@
               </a:lnSpc>
             </a:pPr>
             <a:r>
-              <a:rPr sz="1000" b="0" i="0">
+              <a:rPr sz="1050" b="0" i="0">
                 <a:solidFill>
                   <a:srgbClr val="AEBBD2"/>
                 </a:solidFill>
                 <a:latin typeface="Arial"/>
               </a:rPr>
-              <a:t>Consume the existing inventory and control-point metadata to generate or enforce protection.</a:t>
+              <a:t>More banking processes and workflow patterns beyond Paper 1's evaluation set.</a:t>
             </a:r>
           </a:p>
         </p:txBody>
@@ -5945,8 +5267,8 @@
         </p:nvSpPr>
         <p:spPr>
           <a:xfrm>
-            <a:off x="7205472" y="2286000"/>
-            <a:ext cx="2121408" cy="3566160"/>
+            <a:off x="8796528" y="2286000"/>
+            <a:ext cx="2606040" cy="3566160"/>
           </a:xfrm>
           <a:prstGeom prst="roundRect">
             <a:avLst>
@@ -5993,8 +5315,8 @@
         </p:nvSpPr>
         <p:spPr>
           <a:xfrm>
-            <a:off x="7370064" y="2404872"/>
-            <a:ext cx="1792224" cy="274320"/>
+            <a:off x="8961120" y="2404872"/>
+            <a:ext cx="2276856" cy="274320"/>
           </a:xfrm>
           <a:prstGeom prst="rect">
             <a:avLst/>
@@ -6019,7 +5341,7 @@
                 </a:solidFill>
                 <a:latin typeface="Arial"/>
               </a:rPr>
-              <a:t>Additional banking workloads</a:t>
+              <a:t>Minimal UI</a:t>
             </a:r>
           </a:p>
         </p:txBody>
@@ -6032,8 +5354,8 @@
         </p:nvSpPr>
         <p:spPr>
           <a:xfrm>
-            <a:off x="7370064" y="2724912"/>
-            <a:ext cx="1792224" cy="3017520"/>
+            <a:off x="8961120" y="2724912"/>
+            <a:ext cx="2276856" cy="3017520"/>
           </a:xfrm>
           <a:prstGeom prst="rect">
             <a:avLst/>
@@ -6052,133 +5374,7 @@
               </a:lnSpc>
             </a:pPr>
             <a:r>
-              <a:rPr sz="1000" b="0" i="0">
-                <a:solidFill>
-                  <a:srgbClr val="AEBBD2"/>
-                </a:solidFill>
-                <a:latin typeface="Arial"/>
-              </a:rPr>
-              <a:t>More banking processes and workflow patterns beyond Paper 1's evaluation set.</a:t>
-            </a:r>
-          </a:p>
-        </p:txBody>
-      </p:sp>
-      <p:sp>
-        <p:nvSpPr>
-          <p:cNvPr id="20" name="Rounded Rectangle 19"/>
-          <p:cNvSpPr/>
-          <p:nvPr/>
-        </p:nvSpPr>
-        <p:spPr>
-          <a:xfrm>
-            <a:off x="9418320" y="2286000"/>
-            <a:ext cx="2121408" cy="3566160"/>
-          </a:xfrm>
-          <a:prstGeom prst="roundRect">
-            <a:avLst>
-              <a:gd name="adj" fmla="val 7000"/>
-            </a:avLst>
-          </a:prstGeom>
-          <a:solidFill>
-            <a:srgbClr val="14274A"/>
-          </a:solidFill>
-          <a:ln w="9525">
-            <a:solidFill>
-              <a:srgbClr val="2E466E"/>
-            </a:solidFill>
-          </a:ln>
-          <a:effectLst/>
-        </p:spPr>
-        <p:style>
-          <a:lnRef idx="1">
-            <a:schemeClr val="accent1"/>
-          </a:lnRef>
-          <a:fillRef idx="3">
-            <a:schemeClr val="accent1"/>
-          </a:fillRef>
-          <a:effectRef idx="2">
-            <a:schemeClr val="accent1"/>
-          </a:effectRef>
-          <a:fontRef idx="minor">
-            <a:schemeClr val="lt1"/>
-          </a:fontRef>
-        </p:style>
-        <p:txBody>
-          <a:bodyPr rtlCol="0" anchor="ctr"/>
-          <a:lstStyle/>
-          <a:p>
-            <a:pPr algn="ctr"/>
-          </a:p>
-        </p:txBody>
-      </p:sp>
-      <p:sp>
-        <p:nvSpPr>
-          <p:cNvPr id="21" name="TextBox 20"/>
-          <p:cNvSpPr txBox="1"/>
-          <p:nvPr/>
-        </p:nvSpPr>
-        <p:spPr>
-          <a:xfrm>
-            <a:off x="9582912" y="2404872"/>
-            <a:ext cx="1792224" cy="274320"/>
-          </a:xfrm>
-          <a:prstGeom prst="rect">
-            <a:avLst/>
-          </a:prstGeom>
-          <a:noFill/>
-        </p:spPr>
-        <p:txBody>
-          <a:bodyPr wrap="square" anchor="t" lIns="0" rIns="0" tIns="0" bIns="0">
-            <a:spAutoFit/>
-          </a:bodyPr>
-          <a:lstStyle/>
-          <a:p>
-            <a:pPr algn="l">
-              <a:lnSpc>
-                <a:spcPct val="115000"/>
-              </a:lnSpc>
-            </a:pPr>
-            <a:r>
-              <a:rPr sz="1250" b="1" i="0">
-                <a:solidFill>
-                  <a:srgbClr val="EEF2F8"/>
-                </a:solidFill>
-                <a:latin typeface="Arial"/>
-              </a:rPr>
-              <a:t>Minimal UI</a:t>
-            </a:r>
-          </a:p>
-        </p:txBody>
-      </p:sp>
-      <p:sp>
-        <p:nvSpPr>
-          <p:cNvPr id="22" name="TextBox 21"/>
-          <p:cNvSpPr txBox="1"/>
-          <p:nvPr/>
-        </p:nvSpPr>
-        <p:spPr>
-          <a:xfrm>
-            <a:off x="9582912" y="2724912"/>
-            <a:ext cx="1792224" cy="3017520"/>
-          </a:xfrm>
-          <a:prstGeom prst="rect">
-            <a:avLst/>
-          </a:prstGeom>
-          <a:noFill/>
-        </p:spPr>
-        <p:txBody>
-          <a:bodyPr wrap="square" anchor="t" lIns="0" rIns="0" tIns="0" bIns="0">
-            <a:spAutoFit/>
-          </a:bodyPr>
-          <a:lstStyle/>
-          <a:p>
-            <a:pPr algn="l">
-              <a:lnSpc>
-                <a:spcPct val="122000"/>
-              </a:lnSpc>
-            </a:pPr>
-            <a:r>
-              <a:rPr sz="1000" b="0" i="0">
+              <a:rPr sz="1050" b="0" i="0">
                 <a:solidFill>
                   <a:srgbClr val="AEBBD2"/>
                 </a:solidFill>
@@ -6191,7 +5387,7 @@
       </p:sp>
       <p:cxnSp>
         <p:nvCxnSpPr>
-          <p:cNvPr id="23" name="Connector 22"/>
+          <p:cNvPr id="20" name="Connector 19"/>
           <p:cNvCxnSpPr/>
           <p:nvPr/>
         </p:nvCxnSpPr>
@@ -6226,7 +5422,7 @@
       </p:cxnSp>
       <p:cxnSp>
         <p:nvCxnSpPr>
-          <p:cNvPr id="24" name="Connector 23"/>
+          <p:cNvPr id="21" name="Connector 20"/>
           <p:cNvCxnSpPr/>
           <p:nvPr/>
         </p:nvCxnSpPr>
@@ -6261,7 +5457,7 @@
       </p:cxnSp>
       <p:sp>
         <p:nvSpPr>
-          <p:cNvPr id="25" name="TextBox 24"/>
+          <p:cNvPr id="22" name="TextBox 21"/>
           <p:cNvSpPr txBox="1"/>
           <p:nvPr/>
         </p:nvSpPr>
@@ -6300,7 +5496,7 @@
       </p:sp>
       <p:sp>
         <p:nvSpPr>
-          <p:cNvPr id="26" name="TextBox 25"/>
+          <p:cNvPr id="23" name="TextBox 22"/>
           <p:cNvSpPr txBox="1"/>
           <p:nvPr/>
         </p:nvSpPr>
@@ -6551,7 +5747,7 @@
                 </a:solidFill>
                 <a:latin typeface="Consolas"/>
               </a:rPr>
-              <a:t>EXTENSION 1 OF 5 — ADDITIONAL EXPORTERS</a:t>
+              <a:t>EXTENSION 1 OF 4 — ADDITIONAL EXPORTERS</a:t>
             </a:r>
           </a:p>
         </p:txBody>
@@ -7399,7 +6595,7 @@
                 </a:solidFill>
                 <a:latin typeface="Consolas"/>
               </a:rPr>
-              <a:t>EXTENSION 2 OF 5 — SECURITY MECHANISM PLUGINS</a:t>
+              <a:t>EXTENSION 2 OF 4 — SECURITY MECHANISM PLUGINS</a:t>
             </a:r>
           </a:p>
         </p:txBody>
@@ -8227,7 +7423,7 @@
                 </a:solidFill>
                 <a:latin typeface="Consolas"/>
               </a:rPr>
-              <a:t>EXTENSION 3 OF 5 — ZERO TRUST BACKPLANE</a:t>
+              <a:t>EXTENSION 3 OF 4 — ADDITIONAL BANKING WORKLOADS</a:t>
             </a:r>
           </a:p>
         </p:txBody>
@@ -8260,13 +7456,13 @@
               </a:lnSpc>
             </a:pPr>
             <a:r>
-              <a:rPr sz="2100" b="1" i="0">
+              <a:rPr sz="2300" b="1" i="0">
                 <a:solidFill>
                   <a:srgbClr val="EEF2F8"/>
                 </a:solidFill>
                 <a:latin typeface="Arial Black"/>
               </a:rPr>
-              <a:t>A real, independent Zero Trust project — and where MANTIS plugs in</a:t>
+              <a:t>A genuinely new process, not a new prompt</a:t>
             </a:r>
           </a:p>
         </p:txBody>
@@ -8353,7 +7549,7 @@
                 </a:solidFill>
                 <a:latin typeface="Arial"/>
               </a:rPr>
-              <a:t>The real project</a:t>
+              <a:t>What it is</a:t>
             </a:r>
           </a:p>
         </p:txBody>
@@ -8392,7 +7588,7 @@
                 </a:solidFill>
                 <a:latin typeface="Arial"/>
               </a:rPr>
-              <a:t>A separate, substantially more complete Zero Trust Backplane already exists for this same banking testbed: source-code scanning, PEP placement, a signed PDP, and short-lived signed Permit Leases — already protecting real read and write operations.</a:t>
+              <a:t>Dispute filing and status lookup — a third route under the front-office router, alongside the existing transaction-review and chatbot workflows. A new tool-backed agent and a real case record, not a new prompt into an existing workflow.</a:t>
             </a:r>
           </a:p>
         </p:txBody>
@@ -8479,7 +7675,7 @@
                 </a:solidFill>
                 <a:latin typeface="Arial"/>
               </a:rPr>
-              <a:t>MANTIS's role</a:t>
+              <a:t>Distinct from the existing chatbot</a:t>
             </a:r>
           </a:p>
         </p:txBody>
@@ -8518,7 +7714,7 @@
                 </a:solidFill>
                 <a:latin typeface="Arial"/>
               </a:rPr>
-              <a:t>That project discovers agents/tools by scanning source code into a canonical-ID manifest. MANTIS's inventory() already reports that same information live — a substitute data source for its scanner, not a competing implementation.</a:t>
+              <a:t>The chatbot already answers "how do I dispute a transaction" as an FAQ. This is different: it actually files a case, persists it, and returns a real dispute ID the customer can reference.</a:t>
             </a:r>
           </a:p>
         </p:txBody>
@@ -8605,7 +7801,7 @@
                 </a:solidFill>
                 <a:latin typeface="Arial"/>
               </a:rPr>
-              <a:t>What we built here</a:t>
+              <a:t>What three live trials with zero tool calls taught us</a:t>
             </a:r>
           </a:p>
         </p:txBody>
@@ -8644,7 +7840,7 @@
                 </a:solidFill>
                 <a:latin typeface="Arial"/>
               </a:rPr>
-              <a:t>A representative slice, kept entirely outside MANTIS's own code: a policy generator (default-deny by domain) and an enforcement plugin, registered into the same hook bus every attack plugin uses. It self-registers only when explicitly imported — MANTIS never depends on it existing.</a:t>
+              <a:t>First attempt: real routing worked, but the agent called no tool at all, three times in a row. Cause: the scenario prompt never stated a customer id, unlike every other scenario in the codebase — and file_dispute needs one. Fixed the prompt, not the tool. Next run: real case filed, real ID returned, correct customer message.</a:t>
             </a:r>
           </a:p>
         </p:txBody>
@@ -9011,7 +8207,7 @@
                 </a:solidFill>
                 <a:latin typeface="Consolas"/>
               </a:rPr>
-              <a:t>EXTENSION 3 OF 5 — ZERO TRUST BACKPLANE</a:t>
+              <a:t>EXTENSION 4 OF 4 — MINIMAL UI</a:t>
             </a:r>
           </a:p>
         </p:txBody>
@@ -9044,13 +8240,13 @@
               </a:lnSpc>
             </a:pPr>
             <a:r>
-              <a:rPr sz="2000" b="1" i="0">
+              <a:rPr sz="2200" b="1" i="0">
                 <a:solidFill>
                   <a:srgbClr val="EEF2F8"/>
                 </a:solidFill>
                 <a:latin typeface="Arial Black"/>
               </a:rPr>
-              <a:t>Building the policy generator found a real gap in Paper 1's own inventory</a:t>
+              <a:t>A thin layer over the real CLI, not a second implementation</a:t>
             </a:r>
           </a:p>
         </p:txBody>
@@ -9137,7 +8333,7 @@
                 </a:solidFill>
                 <a:latin typeface="Arial"/>
               </a:rPr>
-              <a:t>The problem</a:t>
+              <a:t>What it is</a:t>
             </a:r>
           </a:p>
         </p:txBody>
@@ -9176,7 +8372,7 @@
                 </a:solidFill>
                 <a:latin typeface="Arial"/>
               </a:rPr>
-              <a:t>A default-deny-by-domain policy is meaningless if every domain reports being able to call every tool. That's exactly what inventory() did — every domain got the full merged tool list, not its own real subset.</a:t>
+              <a:t>A schema-driven experiment editor and trace viewer. Domain/workflow/scenario/plugin dropdowns are populated live from the same registries the CLI reads — not a hardcoded list that can drift.</a:t>
             </a:r>
           </a:p>
         </p:txBody>
@@ -9263,7 +8459,7 @@
                 </a:solidFill>
                 <a:latin typeface="Arial"/>
               </a:rPr>
-              <a:t>The fix</a:t>
+              <a:t>"No separate business logic", verified</a:t>
             </a:r>
           </a:p>
         </p:txBody>
@@ -9302,7 +8498,7 @@
                 </a:solidFill>
                 <a:latin typeface="Arial"/>
               </a:rPr>
-              <a:t>Tools ARE domain-tagged — by which module a domain's agents actually import from. Fixed inventory() to report each domain's real tool subset; added regression tests confirming a back-office-only tool is unreachable from front/mid office.</a:t>
+              <a:t>Validate and Run shell out to the real mantis CLI as a subprocess. Submitted a config with a deliberately invalid domain: got the real CLI's own "Unknown domain" error back, not a UI-side check.</a:t>
             </a:r>
           </a:p>
         </p:txBody>
@@ -9316,7 +8512,7 @@
         <p:spPr>
           <a:xfrm>
             <a:off x="566928" y="4160520"/>
-            <a:ext cx="11064240" cy="1783080"/>
+            <a:ext cx="11064240" cy="1600200"/>
           </a:xfrm>
           <a:prstGeom prst="roundRect">
             <a:avLst>
@@ -9389,7 +8585,7 @@
                 </a:solidFill>
                 <a:latin typeface="Arial"/>
               </a:rPr>
-              <a:t>Then we went deeper: exhaustive trials, and a second real bug</a:t>
+              <a:t>Confirmed as a real running server</a:t>
             </a:r>
           </a:p>
         </p:txBody>
@@ -9403,7 +8599,7 @@
         <p:spPr>
           <a:xfrm>
             <a:off x="731520" y="4599432"/>
-            <a:ext cx="10735056" cy="1234440"/>
+            <a:ext cx="10735056" cy="1051560"/>
           </a:xfrm>
           <a:prstGeom prst="rect">
             <a:avLst/>
@@ -9422,13 +8618,13 @@
               </a:lnSpc>
             </a:pPr>
             <a:r>
-              <a:rPr sz="1050" b="0" i="0">
+              <a:rPr sz="1150" b="0" i="0">
                 <a:solidFill>
                   <a:srgbClr val="EEF2F8"/>
                 </a:solidFill>
                 <a:latin typeface="Arial"/>
               </a:rPr>
-              <a:t>770/770 (agent, tool) pairs from the live policy correctly enforced (495 cross-domain denied, 275 in-domain allowed) — every combination the live system has, not a handful of examples. 5/5 live trials: zero false-positive denials on legitimate traffic. Building that harness found a second defect: this plugin's own denials were being silently recorded as ATTACK_INJECTED, not POLICY_EVENT — a defense misclassified as the attack it was stopping. Fixed, with a regression test through the real hook bus.</a:t>
+              <a:t>Launched via mantis --ui and queried over real HTTP, not just an in-process test client: correctly reported the live inventory (32 agents, 22 tools) and every existing run artifact (27 runs) at the time of this check.</a:t>
             </a:r>
           </a:p>
         </p:txBody>
@@ -9795,7 +8991,7 @@
                 </a:solidFill>
                 <a:latin typeface="Consolas"/>
               </a:rPr>
-              <a:t>EXTENSION 4 OF 5 — ADDITIONAL BANKING WORKLOADS</a:t>
+              <a:t>EVALUATION SUMMARY</a:t>
             </a:r>
           </a:p>
         </p:txBody>
@@ -9828,1581 +9024,13 @@
               </a:lnSpc>
             </a:pPr>
             <a:r>
-              <a:rPr sz="2300" b="1" i="0">
+              <a:rPr sz="2200" b="1" i="0">
                 <a:solidFill>
                   <a:srgbClr val="EEF2F8"/>
                 </a:solidFill>
                 <a:latin typeface="Arial Black"/>
               </a:rPr>
-              <a:t>A genuinely new process, not a new prompt</a:t>
-            </a:r>
-          </a:p>
-        </p:txBody>
-      </p:sp>
-      <p:sp>
-        <p:nvSpPr>
-          <p:cNvPr id="7" name="Rounded Rectangle 6"/>
-          <p:cNvSpPr/>
-          <p:nvPr/>
-        </p:nvSpPr>
-        <p:spPr>
-          <a:xfrm>
-            <a:off x="566928" y="1691640"/>
-            <a:ext cx="5349240" cy="2331720"/>
-          </a:xfrm>
-          <a:prstGeom prst="roundRect">
-            <a:avLst>
-              <a:gd name="adj" fmla="val 7000"/>
-            </a:avLst>
-          </a:prstGeom>
-          <a:solidFill>
-            <a:srgbClr val="14274A"/>
-          </a:solidFill>
-          <a:ln w="9525">
-            <a:solidFill>
-              <a:srgbClr val="2E466E"/>
-            </a:solidFill>
-          </a:ln>
-          <a:effectLst/>
-        </p:spPr>
-        <p:style>
-          <a:lnRef idx="1">
-            <a:schemeClr val="accent1"/>
-          </a:lnRef>
-          <a:fillRef idx="3">
-            <a:schemeClr val="accent1"/>
-          </a:fillRef>
-          <a:effectRef idx="2">
-            <a:schemeClr val="accent1"/>
-          </a:effectRef>
-          <a:fontRef idx="minor">
-            <a:schemeClr val="lt1"/>
-          </a:fontRef>
-        </p:style>
-        <p:txBody>
-          <a:bodyPr rtlCol="0" anchor="ctr"/>
-          <a:lstStyle/>
-          <a:p>
-            <a:pPr algn="ctr"/>
-          </a:p>
-        </p:txBody>
-      </p:sp>
-      <p:sp>
-        <p:nvSpPr>
-          <p:cNvPr id="8" name="TextBox 7"/>
-          <p:cNvSpPr txBox="1"/>
-          <p:nvPr/>
-        </p:nvSpPr>
-        <p:spPr>
-          <a:xfrm>
-            <a:off x="731520" y="1810512"/>
-            <a:ext cx="5020056" cy="274320"/>
-          </a:xfrm>
-          <a:prstGeom prst="rect">
-            <a:avLst/>
-          </a:prstGeom>
-          <a:noFill/>
-        </p:spPr>
-        <p:txBody>
-          <a:bodyPr wrap="square" anchor="t" lIns="0" rIns="0" tIns="0" bIns="0">
-            <a:spAutoFit/>
-          </a:bodyPr>
-          <a:lstStyle/>
-          <a:p>
-            <a:pPr algn="l">
-              <a:lnSpc>
-                <a:spcPct val="115000"/>
-              </a:lnSpc>
-            </a:pPr>
-            <a:r>
-              <a:rPr sz="1250" b="1" i="0">
-                <a:solidFill>
-                  <a:srgbClr val="EEF2F8"/>
-                </a:solidFill>
-                <a:latin typeface="Arial"/>
-              </a:rPr>
-              <a:t>What it is</a:t>
-            </a:r>
-          </a:p>
-        </p:txBody>
-      </p:sp>
-      <p:sp>
-        <p:nvSpPr>
-          <p:cNvPr id="9" name="TextBox 8"/>
-          <p:cNvSpPr txBox="1"/>
-          <p:nvPr/>
-        </p:nvSpPr>
-        <p:spPr>
-          <a:xfrm>
-            <a:off x="731520" y="2130552"/>
-            <a:ext cx="5020056" cy="1783080"/>
-          </a:xfrm>
-          <a:prstGeom prst="rect">
-            <a:avLst/>
-          </a:prstGeom>
-          <a:noFill/>
-        </p:spPr>
-        <p:txBody>
-          <a:bodyPr wrap="square" anchor="t" lIns="0" rIns="0" tIns="0" bIns="0">
-            <a:spAutoFit/>
-          </a:bodyPr>
-          <a:lstStyle/>
-          <a:p>
-            <a:pPr algn="l">
-              <a:lnSpc>
-                <a:spcPct val="122000"/>
-              </a:lnSpc>
-            </a:pPr>
-            <a:r>
-              <a:rPr sz="1100" b="0" i="0">
-                <a:solidFill>
-                  <a:srgbClr val="AEBBD2"/>
-                </a:solidFill>
-                <a:latin typeface="Arial"/>
-              </a:rPr>
-              <a:t>Dispute filing and status lookup — a third route under the front-office router, alongside the existing transaction-review and chatbot workflows. A new tool-backed agent and a real case record, not a new prompt into an existing workflow.</a:t>
-            </a:r>
-          </a:p>
-        </p:txBody>
-      </p:sp>
-      <p:sp>
-        <p:nvSpPr>
-          <p:cNvPr id="10" name="Rounded Rectangle 9"/>
-          <p:cNvSpPr/>
-          <p:nvPr/>
-        </p:nvSpPr>
-        <p:spPr>
-          <a:xfrm>
-            <a:off x="6080760" y="1691640"/>
-            <a:ext cx="5532120" cy="2331720"/>
-          </a:xfrm>
-          <a:prstGeom prst="roundRect">
-            <a:avLst>
-              <a:gd name="adj" fmla="val 7000"/>
-            </a:avLst>
-          </a:prstGeom>
-          <a:solidFill>
-            <a:srgbClr val="14274A"/>
-          </a:solidFill>
-          <a:ln w="9525">
-            <a:solidFill>
-              <a:srgbClr val="2E466E"/>
-            </a:solidFill>
-          </a:ln>
-          <a:effectLst/>
-        </p:spPr>
-        <p:style>
-          <a:lnRef idx="1">
-            <a:schemeClr val="accent1"/>
-          </a:lnRef>
-          <a:fillRef idx="3">
-            <a:schemeClr val="accent1"/>
-          </a:fillRef>
-          <a:effectRef idx="2">
-            <a:schemeClr val="accent1"/>
-          </a:effectRef>
-          <a:fontRef idx="minor">
-            <a:schemeClr val="lt1"/>
-          </a:fontRef>
-        </p:style>
-        <p:txBody>
-          <a:bodyPr rtlCol="0" anchor="ctr"/>
-          <a:lstStyle/>
-          <a:p>
-            <a:pPr algn="ctr"/>
-          </a:p>
-        </p:txBody>
-      </p:sp>
-      <p:sp>
-        <p:nvSpPr>
-          <p:cNvPr id="11" name="TextBox 10"/>
-          <p:cNvSpPr txBox="1"/>
-          <p:nvPr/>
-        </p:nvSpPr>
-        <p:spPr>
-          <a:xfrm>
-            <a:off x="6245352" y="1810512"/>
-            <a:ext cx="5202936" cy="274320"/>
-          </a:xfrm>
-          <a:prstGeom prst="rect">
-            <a:avLst/>
-          </a:prstGeom>
-          <a:noFill/>
-        </p:spPr>
-        <p:txBody>
-          <a:bodyPr wrap="square" anchor="t" lIns="0" rIns="0" tIns="0" bIns="0">
-            <a:spAutoFit/>
-          </a:bodyPr>
-          <a:lstStyle/>
-          <a:p>
-            <a:pPr algn="l">
-              <a:lnSpc>
-                <a:spcPct val="115000"/>
-              </a:lnSpc>
-            </a:pPr>
-            <a:r>
-              <a:rPr sz="1250" b="1" i="0">
-                <a:solidFill>
-                  <a:srgbClr val="EEF2F8"/>
-                </a:solidFill>
-                <a:latin typeface="Arial"/>
-              </a:rPr>
-              <a:t>Distinct from the existing chatbot</a:t>
-            </a:r>
-          </a:p>
-        </p:txBody>
-      </p:sp>
-      <p:sp>
-        <p:nvSpPr>
-          <p:cNvPr id="12" name="TextBox 11"/>
-          <p:cNvSpPr txBox="1"/>
-          <p:nvPr/>
-        </p:nvSpPr>
-        <p:spPr>
-          <a:xfrm>
-            <a:off x="6245352" y="2130552"/>
-            <a:ext cx="5202936" cy="1783080"/>
-          </a:xfrm>
-          <a:prstGeom prst="rect">
-            <a:avLst/>
-          </a:prstGeom>
-          <a:noFill/>
-        </p:spPr>
-        <p:txBody>
-          <a:bodyPr wrap="square" anchor="t" lIns="0" rIns="0" tIns="0" bIns="0">
-            <a:spAutoFit/>
-          </a:bodyPr>
-          <a:lstStyle/>
-          <a:p>
-            <a:pPr algn="l">
-              <a:lnSpc>
-                <a:spcPct val="122000"/>
-              </a:lnSpc>
-            </a:pPr>
-            <a:r>
-              <a:rPr sz="1100" b="0" i="0">
-                <a:solidFill>
-                  <a:srgbClr val="AEBBD2"/>
-                </a:solidFill>
-                <a:latin typeface="Arial"/>
-              </a:rPr>
-              <a:t>The chatbot already answers "how do I dispute a transaction" as an FAQ. This is different: it actually files a case, persists it, and returns a real dispute ID the customer can reference.</a:t>
-            </a:r>
-          </a:p>
-        </p:txBody>
-      </p:sp>
-      <p:sp>
-        <p:nvSpPr>
-          <p:cNvPr id="13" name="Rounded Rectangle 12"/>
-          <p:cNvSpPr/>
-          <p:nvPr/>
-        </p:nvSpPr>
-        <p:spPr>
-          <a:xfrm>
-            <a:off x="566928" y="4160520"/>
-            <a:ext cx="11064240" cy="1600200"/>
-          </a:xfrm>
-          <a:prstGeom prst="roundRect">
-            <a:avLst>
-              <a:gd name="adj" fmla="val 7000"/>
-            </a:avLst>
-          </a:prstGeom>
-          <a:solidFill>
-            <a:srgbClr val="331E14"/>
-          </a:solidFill>
-          <a:ln w="9525">
-            <a:solidFill>
-              <a:srgbClr val="FA4616"/>
-            </a:solidFill>
-          </a:ln>
-          <a:effectLst/>
-        </p:spPr>
-        <p:style>
-          <a:lnRef idx="1">
-            <a:schemeClr val="accent1"/>
-          </a:lnRef>
-          <a:fillRef idx="3">
-            <a:schemeClr val="accent1"/>
-          </a:fillRef>
-          <a:effectRef idx="2">
-            <a:schemeClr val="accent1"/>
-          </a:effectRef>
-          <a:fontRef idx="minor">
-            <a:schemeClr val="lt1"/>
-          </a:fontRef>
-        </p:style>
-        <p:txBody>
-          <a:bodyPr rtlCol="0" anchor="ctr"/>
-          <a:lstStyle/>
-          <a:p>
-            <a:pPr algn="ctr"/>
-          </a:p>
-        </p:txBody>
-      </p:sp>
-      <p:sp>
-        <p:nvSpPr>
-          <p:cNvPr id="14" name="TextBox 13"/>
-          <p:cNvSpPr txBox="1"/>
-          <p:nvPr/>
-        </p:nvSpPr>
-        <p:spPr>
-          <a:xfrm>
-            <a:off x="731520" y="4279392"/>
-            <a:ext cx="10735056" cy="274320"/>
-          </a:xfrm>
-          <a:prstGeom prst="rect">
-            <a:avLst/>
-          </a:prstGeom>
-          <a:noFill/>
-        </p:spPr>
-        <p:txBody>
-          <a:bodyPr wrap="square" anchor="t" lIns="0" rIns="0" tIns="0" bIns="0">
-            <a:spAutoFit/>
-          </a:bodyPr>
-          <a:lstStyle/>
-          <a:p>
-            <a:pPr algn="l">
-              <a:lnSpc>
-                <a:spcPct val="115000"/>
-              </a:lnSpc>
-            </a:pPr>
-            <a:r>
-              <a:rPr sz="1250" b="1" i="0">
-                <a:solidFill>
-                  <a:srgbClr val="FF8A5C"/>
-                </a:solidFill>
-                <a:latin typeface="Arial"/>
-              </a:rPr>
-              <a:t>What three live trials with zero tool calls taught us</a:t>
-            </a:r>
-          </a:p>
-        </p:txBody>
-      </p:sp>
-      <p:sp>
-        <p:nvSpPr>
-          <p:cNvPr id="15" name="TextBox 14"/>
-          <p:cNvSpPr txBox="1"/>
-          <p:nvPr/>
-        </p:nvSpPr>
-        <p:spPr>
-          <a:xfrm>
-            <a:off x="731520" y="4599432"/>
-            <a:ext cx="10735056" cy="1051560"/>
-          </a:xfrm>
-          <a:prstGeom prst="rect">
-            <a:avLst/>
-          </a:prstGeom>
-          <a:noFill/>
-        </p:spPr>
-        <p:txBody>
-          <a:bodyPr wrap="square" anchor="t" lIns="0" rIns="0" tIns="0" bIns="0">
-            <a:spAutoFit/>
-          </a:bodyPr>
-          <a:lstStyle/>
-          <a:p>
-            <a:pPr algn="l">
-              <a:lnSpc>
-                <a:spcPct val="122000"/>
-              </a:lnSpc>
-            </a:pPr>
-            <a:r>
-              <a:rPr sz="1100" b="0" i="0">
-                <a:solidFill>
-                  <a:srgbClr val="EEF2F8"/>
-                </a:solidFill>
-                <a:latin typeface="Arial"/>
-              </a:rPr>
-              <a:t>First attempt: real routing worked, but the agent called no tool at all, three times in a row. Cause: the scenario prompt never stated a customer id, unlike every other scenario in the codebase — and file_dispute needs one. Fixed the prompt, not the tool. Next run: real case filed, real ID returned, correct customer message.</a:t>
-            </a:r>
-          </a:p>
-        </p:txBody>
-      </p:sp>
-      <p:cxnSp>
-        <p:nvCxnSpPr>
-          <p:cNvPr id="16" name="Connector 15"/>
-          <p:cNvCxnSpPr/>
-          <p:nvPr/>
-        </p:nvCxnSpPr>
-        <p:spPr>
-          <a:xfrm>
-            <a:off x="566928" y="6382512"/>
-            <a:ext cx="2377440" cy="0"/>
-          </a:xfrm>
-          <a:prstGeom prst="line">
-            <a:avLst/>
-          </a:prstGeom>
-          <a:ln w="9525">
-            <a:solidFill>
-              <a:srgbClr val="7E8FAE"/>
-            </a:solidFill>
-          </a:ln>
-        </p:spPr>
-        <p:style>
-          <a:lnRef idx="2">
-            <a:schemeClr val="accent1"/>
-          </a:lnRef>
-          <a:fillRef idx="0">
-            <a:schemeClr val="accent1"/>
-          </a:fillRef>
-          <a:effectRef idx="1">
-            <a:schemeClr val="accent1"/>
-          </a:effectRef>
-          <a:fontRef idx="minor">
-            <a:schemeClr val="tx1"/>
-          </a:fontRef>
-        </p:style>
-      </p:cxnSp>
-      <p:cxnSp>
-        <p:nvCxnSpPr>
-          <p:cNvPr id="17" name="Connector 16"/>
-          <p:cNvCxnSpPr/>
-          <p:nvPr/>
-        </p:nvCxnSpPr>
-        <p:spPr>
-          <a:xfrm>
-            <a:off x="9326880" y="6382512"/>
-            <a:ext cx="2286000" cy="0"/>
-          </a:xfrm>
-          <a:prstGeom prst="line">
-            <a:avLst/>
-          </a:prstGeom>
-          <a:ln w="9525">
-            <a:solidFill>
-              <a:srgbClr val="7E8FAE"/>
-            </a:solidFill>
-          </a:ln>
-        </p:spPr>
-        <p:style>
-          <a:lnRef idx="2">
-            <a:schemeClr val="accent1"/>
-          </a:lnRef>
-          <a:fillRef idx="0">
-            <a:schemeClr val="accent1"/>
-          </a:fillRef>
-          <a:effectRef idx="1">
-            <a:schemeClr val="accent1"/>
-          </a:effectRef>
-          <a:fontRef idx="minor">
-            <a:schemeClr val="tx1"/>
-          </a:fontRef>
-        </p:style>
-      </p:cxnSp>
-      <p:sp>
-        <p:nvSpPr>
-          <p:cNvPr id="18" name="TextBox 17"/>
-          <p:cNvSpPr txBox="1"/>
-          <p:nvPr/>
-        </p:nvSpPr>
-        <p:spPr>
-          <a:xfrm>
-            <a:off x="3017520" y="6281928"/>
-            <a:ext cx="6217920" cy="256032"/>
-          </a:xfrm>
-          <a:prstGeom prst="rect">
-            <a:avLst/>
-          </a:prstGeom>
-          <a:noFill/>
-        </p:spPr>
-        <p:txBody>
-          <a:bodyPr wrap="square" anchor="t" lIns="0" rIns="0" tIns="0" bIns="0">
-            <a:spAutoFit/>
-          </a:bodyPr>
-          <a:lstStyle/>
-          <a:p>
-            <a:pPr algn="ctr">
-              <a:lnSpc>
-                <a:spcPct val="115000"/>
-              </a:lnSpc>
-            </a:pPr>
-            <a:r>
-              <a:rPr sz="800" b="0" i="0">
-                <a:solidFill>
-                  <a:srgbClr val="7E8FAE"/>
-                </a:solidFill>
-                <a:latin typeface="Consolas"/>
-              </a:rPr>
-              <a:t>MANTIS EXTENDED — POST-PAPER EXTENSIONS</a:t>
-            </a:r>
-          </a:p>
-        </p:txBody>
-      </p:sp>
-      <p:sp>
-        <p:nvSpPr>
-          <p:cNvPr id="19" name="TextBox 18"/>
-          <p:cNvSpPr txBox="1"/>
-          <p:nvPr/>
-        </p:nvSpPr>
-        <p:spPr>
-          <a:xfrm>
-            <a:off x="11430000" y="6281928"/>
-            <a:ext cx="548640" cy="256032"/>
-          </a:xfrm>
-          <a:prstGeom prst="rect">
-            <a:avLst/>
-          </a:prstGeom>
-          <a:noFill/>
-        </p:spPr>
-        <p:txBody>
-          <a:bodyPr wrap="square" anchor="t" lIns="0" rIns="0" tIns="0" bIns="0">
-            <a:spAutoFit/>
-          </a:bodyPr>
-          <a:lstStyle/>
-          <a:p>
-            <a:pPr algn="r">
-              <a:lnSpc>
-                <a:spcPct val="115000"/>
-              </a:lnSpc>
-            </a:pPr>
-            <a:r>
-              <a:rPr sz="900" b="1" i="0">
-                <a:solidFill>
-                  <a:srgbClr val="AEBBD2"/>
-                </a:solidFill>
-                <a:latin typeface="Consolas"/>
-              </a:rPr>
-              <a:t>7</a:t>
-            </a:r>
-          </a:p>
-        </p:txBody>
-      </p:sp>
-    </p:spTree>
-  </p:cSld>
-  <p:clrMapOvr>
-    <a:masterClrMapping/>
-  </p:clrMapOvr>
-</p:sld>
-</file>
-
-<file path=ppt/slides/slide8.xml><?xml version="1.0" encoding="utf-8"?>
-<p:sld xmlns:a="http://schemas.openxmlformats.org/drawingml/2006/main" xmlns:p="http://schemas.openxmlformats.org/presentationml/2006/main" xmlns:r="http://schemas.openxmlformats.org/officeDocument/2006/relationships">
-  <p:cSld>
-    <p:spTree>
-      <p:nvGrpSpPr>
-        <p:cNvPr id="1" name=""/>
-        <p:cNvGrpSpPr/>
-        <p:nvPr/>
-      </p:nvGrpSpPr>
-      <p:grpSpPr/>
-      <p:sp>
-        <p:nvSpPr>
-          <p:cNvPr id="2" name="Rectangle 1"/>
-          <p:cNvSpPr/>
-          <p:nvPr/>
-        </p:nvSpPr>
-        <p:spPr>
-          <a:xfrm>
-            <a:off x="0" y="0"/>
-            <a:ext cx="12191695" cy="6858000"/>
-          </a:xfrm>
-          <a:prstGeom prst="rect">
-            <a:avLst/>
-          </a:prstGeom>
-          <a:solidFill>
-            <a:srgbClr val="071022"/>
-          </a:solidFill>
-          <a:ln>
-            <a:noFill/>
-          </a:ln>
-          <a:effectLst/>
-        </p:spPr>
-        <p:style>
-          <a:lnRef idx="1">
-            <a:schemeClr val="accent1"/>
-          </a:lnRef>
-          <a:fillRef idx="3">
-            <a:schemeClr val="accent1"/>
-          </a:fillRef>
-          <a:effectRef idx="2">
-            <a:schemeClr val="accent1"/>
-          </a:effectRef>
-          <a:fontRef idx="minor">
-            <a:schemeClr val="lt1"/>
-          </a:fontRef>
-        </p:style>
-        <p:txBody>
-          <a:bodyPr rtlCol="0" anchor="ctr"/>
-          <a:lstStyle/>
-          <a:p>
-            <a:pPr algn="ctr"/>
-          </a:p>
-        </p:txBody>
-      </p:sp>
-      <p:sp>
-        <p:nvSpPr>
-          <p:cNvPr id="3" name="Rounded Rectangle 2"/>
-          <p:cNvSpPr/>
-          <p:nvPr/>
-        </p:nvSpPr>
-        <p:spPr>
-          <a:xfrm>
-            <a:off x="566928" y="292608"/>
-            <a:ext cx="310896" cy="310896"/>
-          </a:xfrm>
-          <a:prstGeom prst="roundRect">
-            <a:avLst>
-              <a:gd name="adj" fmla="val 16000"/>
-            </a:avLst>
-          </a:prstGeom>
-          <a:solidFill>
-            <a:srgbClr val="071022"/>
-          </a:solidFill>
-          <a:ln w="15875">
-            <a:solidFill>
-              <a:srgbClr val="EEF2F8"/>
-            </a:solidFill>
-          </a:ln>
-          <a:effectLst/>
-        </p:spPr>
-        <p:style>
-          <a:lnRef idx="1">
-            <a:schemeClr val="accent1"/>
-          </a:lnRef>
-          <a:fillRef idx="3">
-            <a:schemeClr val="accent1"/>
-          </a:fillRef>
-          <a:effectRef idx="2">
-            <a:schemeClr val="accent1"/>
-          </a:effectRef>
-          <a:fontRef idx="minor">
-            <a:schemeClr val="lt1"/>
-          </a:fontRef>
-        </p:style>
-        <p:txBody>
-          <a:bodyPr rtlCol="0" anchor="ctr" lIns="0" rIns="0" tIns="0" bIns="0"/>
-          <a:lstStyle/>
-          <a:p>
-            <a:pPr algn="ctr"/>
-            <a:r>
-              <a:rPr sz="1200" b="1">
-                <a:solidFill>
-                  <a:srgbClr val="EEF2F8"/>
-                </a:solidFill>
-                <a:latin typeface="Arial"/>
-              </a:rPr>
-              <a:t>UF</a:t>
-            </a:r>
-          </a:p>
-        </p:txBody>
-      </p:sp>
-      <p:sp>
-        <p:nvSpPr>
-          <p:cNvPr id="4" name="TextBox 3"/>
-          <p:cNvSpPr txBox="1"/>
-          <p:nvPr/>
-        </p:nvSpPr>
-        <p:spPr>
-          <a:xfrm>
-            <a:off x="969264" y="256032"/>
-            <a:ext cx="3291840" cy="384048"/>
-          </a:xfrm>
-          <a:prstGeom prst="rect">
-            <a:avLst/>
-          </a:prstGeom>
-          <a:noFill/>
-        </p:spPr>
-        <p:txBody>
-          <a:bodyPr wrap="square" anchor="t" lIns="0" rIns="0" tIns="0" bIns="0">
-            <a:spAutoFit/>
-          </a:bodyPr>
-          <a:lstStyle/>
-          <a:p>
-            <a:pPr algn="l">
-              <a:lnSpc>
-                <a:spcPct val="100000"/>
-              </a:lnSpc>
-              <a:spcAft>
-                <a:spcPts val="0"/>
-              </a:spcAft>
-            </a:pPr>
-            <a:r>
-              <a:rPr sz="1050" b="1" i="0">
-                <a:solidFill>
-                  <a:srgbClr val="EEF2F8"/>
-                </a:solidFill>
-                <a:latin typeface="Arial"/>
-              </a:rPr>
-              <a:t>Herbert Wertheim</a:t>
-            </a:r>
-          </a:p>
-          <a:p>
-            <a:pPr algn="l">
-              <a:lnSpc>
-                <a:spcPct val="100000"/>
-              </a:lnSpc>
-              <a:spcAft>
-                <a:spcPts val="0"/>
-              </a:spcAft>
-            </a:pPr>
-            <a:r>
-              <a:rPr sz="900" b="0" i="1">
-                <a:solidFill>
-                  <a:srgbClr val="AEBBD2"/>
-                </a:solidFill>
-                <a:latin typeface="Georgia"/>
-              </a:rPr>
-              <a:t>College of Engineering</a:t>
-            </a:r>
-          </a:p>
-        </p:txBody>
-      </p:sp>
-      <p:sp>
-        <p:nvSpPr>
-          <p:cNvPr id="5" name="TextBox 4"/>
-          <p:cNvSpPr txBox="1"/>
-          <p:nvPr/>
-        </p:nvSpPr>
-        <p:spPr>
-          <a:xfrm>
-            <a:off x="566928" y="896112"/>
-            <a:ext cx="8229600" cy="274320"/>
-          </a:xfrm>
-          <a:prstGeom prst="rect">
-            <a:avLst/>
-          </a:prstGeom>
-          <a:noFill/>
-        </p:spPr>
-        <p:txBody>
-          <a:bodyPr wrap="square" anchor="t" lIns="0" rIns="0" tIns="0" bIns="0">
-            <a:spAutoFit/>
-          </a:bodyPr>
-          <a:lstStyle/>
-          <a:p>
-            <a:pPr algn="l">
-              <a:lnSpc>
-                <a:spcPct val="115000"/>
-              </a:lnSpc>
-            </a:pPr>
-            <a:r>
-              <a:rPr sz="1100" b="1" i="0">
-                <a:solidFill>
-                  <a:srgbClr val="FF8A5C"/>
-                </a:solidFill>
-                <a:latin typeface="Consolas"/>
-              </a:rPr>
-              <a:t>EXTENSION 5 OF 5 — MINIMAL UI</a:t>
-            </a:r>
-          </a:p>
-        </p:txBody>
-      </p:sp>
-      <p:sp>
-        <p:nvSpPr>
-          <p:cNvPr id="6" name="TextBox 5"/>
-          <p:cNvSpPr txBox="1"/>
-          <p:nvPr/>
-        </p:nvSpPr>
-        <p:spPr>
-          <a:xfrm>
-            <a:off x="566928" y="1115568"/>
-            <a:ext cx="10607040" cy="1188720"/>
-          </a:xfrm>
-          <a:prstGeom prst="rect">
-            <a:avLst/>
-          </a:prstGeom>
-          <a:noFill/>
-        </p:spPr>
-        <p:txBody>
-          <a:bodyPr wrap="square" anchor="t" lIns="0" rIns="0" tIns="0" bIns="0">
-            <a:spAutoFit/>
-          </a:bodyPr>
-          <a:lstStyle/>
-          <a:p>
-            <a:pPr algn="l">
-              <a:lnSpc>
-                <a:spcPct val="104000"/>
-              </a:lnSpc>
-            </a:pPr>
-            <a:r>
-              <a:rPr sz="2200" b="1" i="0">
-                <a:solidFill>
-                  <a:srgbClr val="EEF2F8"/>
-                </a:solidFill>
-                <a:latin typeface="Arial Black"/>
-              </a:rPr>
-              <a:t>A thin layer over the real CLI, not a second implementation</a:t>
-            </a:r>
-          </a:p>
-        </p:txBody>
-      </p:sp>
-      <p:sp>
-        <p:nvSpPr>
-          <p:cNvPr id="7" name="Rounded Rectangle 6"/>
-          <p:cNvSpPr/>
-          <p:nvPr/>
-        </p:nvSpPr>
-        <p:spPr>
-          <a:xfrm>
-            <a:off x="566928" y="1691640"/>
-            <a:ext cx="5349240" cy="2331720"/>
-          </a:xfrm>
-          <a:prstGeom prst="roundRect">
-            <a:avLst>
-              <a:gd name="adj" fmla="val 7000"/>
-            </a:avLst>
-          </a:prstGeom>
-          <a:solidFill>
-            <a:srgbClr val="14274A"/>
-          </a:solidFill>
-          <a:ln w="9525">
-            <a:solidFill>
-              <a:srgbClr val="2E466E"/>
-            </a:solidFill>
-          </a:ln>
-          <a:effectLst/>
-        </p:spPr>
-        <p:style>
-          <a:lnRef idx="1">
-            <a:schemeClr val="accent1"/>
-          </a:lnRef>
-          <a:fillRef idx="3">
-            <a:schemeClr val="accent1"/>
-          </a:fillRef>
-          <a:effectRef idx="2">
-            <a:schemeClr val="accent1"/>
-          </a:effectRef>
-          <a:fontRef idx="minor">
-            <a:schemeClr val="lt1"/>
-          </a:fontRef>
-        </p:style>
-        <p:txBody>
-          <a:bodyPr rtlCol="0" anchor="ctr"/>
-          <a:lstStyle/>
-          <a:p>
-            <a:pPr algn="ctr"/>
-          </a:p>
-        </p:txBody>
-      </p:sp>
-      <p:sp>
-        <p:nvSpPr>
-          <p:cNvPr id="8" name="TextBox 7"/>
-          <p:cNvSpPr txBox="1"/>
-          <p:nvPr/>
-        </p:nvSpPr>
-        <p:spPr>
-          <a:xfrm>
-            <a:off x="731520" y="1810512"/>
-            <a:ext cx="5020056" cy="274320"/>
-          </a:xfrm>
-          <a:prstGeom prst="rect">
-            <a:avLst/>
-          </a:prstGeom>
-          <a:noFill/>
-        </p:spPr>
-        <p:txBody>
-          <a:bodyPr wrap="square" anchor="t" lIns="0" rIns="0" tIns="0" bIns="0">
-            <a:spAutoFit/>
-          </a:bodyPr>
-          <a:lstStyle/>
-          <a:p>
-            <a:pPr algn="l">
-              <a:lnSpc>
-                <a:spcPct val="115000"/>
-              </a:lnSpc>
-            </a:pPr>
-            <a:r>
-              <a:rPr sz="1250" b="1" i="0">
-                <a:solidFill>
-                  <a:srgbClr val="EEF2F8"/>
-                </a:solidFill>
-                <a:latin typeface="Arial"/>
-              </a:rPr>
-              <a:t>What it is</a:t>
-            </a:r>
-          </a:p>
-        </p:txBody>
-      </p:sp>
-      <p:sp>
-        <p:nvSpPr>
-          <p:cNvPr id="9" name="TextBox 8"/>
-          <p:cNvSpPr txBox="1"/>
-          <p:nvPr/>
-        </p:nvSpPr>
-        <p:spPr>
-          <a:xfrm>
-            <a:off x="731520" y="2130552"/>
-            <a:ext cx="5020056" cy="1783080"/>
-          </a:xfrm>
-          <a:prstGeom prst="rect">
-            <a:avLst/>
-          </a:prstGeom>
-          <a:noFill/>
-        </p:spPr>
-        <p:txBody>
-          <a:bodyPr wrap="square" anchor="t" lIns="0" rIns="0" tIns="0" bIns="0">
-            <a:spAutoFit/>
-          </a:bodyPr>
-          <a:lstStyle/>
-          <a:p>
-            <a:pPr algn="l">
-              <a:lnSpc>
-                <a:spcPct val="122000"/>
-              </a:lnSpc>
-            </a:pPr>
-            <a:r>
-              <a:rPr sz="1100" b="0" i="0">
-                <a:solidFill>
-                  <a:srgbClr val="AEBBD2"/>
-                </a:solidFill>
-                <a:latin typeface="Arial"/>
-              </a:rPr>
-              <a:t>A schema-driven experiment editor and trace viewer. Domain/workflow/scenario/plugin dropdowns are populated live from the same registries the CLI reads — not a hardcoded list that can drift.</a:t>
-            </a:r>
-          </a:p>
-        </p:txBody>
-      </p:sp>
-      <p:sp>
-        <p:nvSpPr>
-          <p:cNvPr id="10" name="Rounded Rectangle 9"/>
-          <p:cNvSpPr/>
-          <p:nvPr/>
-        </p:nvSpPr>
-        <p:spPr>
-          <a:xfrm>
-            <a:off x="6080760" y="1691640"/>
-            <a:ext cx="5532120" cy="2331720"/>
-          </a:xfrm>
-          <a:prstGeom prst="roundRect">
-            <a:avLst>
-              <a:gd name="adj" fmla="val 7000"/>
-            </a:avLst>
-          </a:prstGeom>
-          <a:solidFill>
-            <a:srgbClr val="14274A"/>
-          </a:solidFill>
-          <a:ln w="9525">
-            <a:solidFill>
-              <a:srgbClr val="2E466E"/>
-            </a:solidFill>
-          </a:ln>
-          <a:effectLst/>
-        </p:spPr>
-        <p:style>
-          <a:lnRef idx="1">
-            <a:schemeClr val="accent1"/>
-          </a:lnRef>
-          <a:fillRef idx="3">
-            <a:schemeClr val="accent1"/>
-          </a:fillRef>
-          <a:effectRef idx="2">
-            <a:schemeClr val="accent1"/>
-          </a:effectRef>
-          <a:fontRef idx="minor">
-            <a:schemeClr val="lt1"/>
-          </a:fontRef>
-        </p:style>
-        <p:txBody>
-          <a:bodyPr rtlCol="0" anchor="ctr"/>
-          <a:lstStyle/>
-          <a:p>
-            <a:pPr algn="ctr"/>
-          </a:p>
-        </p:txBody>
-      </p:sp>
-      <p:sp>
-        <p:nvSpPr>
-          <p:cNvPr id="11" name="TextBox 10"/>
-          <p:cNvSpPr txBox="1"/>
-          <p:nvPr/>
-        </p:nvSpPr>
-        <p:spPr>
-          <a:xfrm>
-            <a:off x="6245352" y="1810512"/>
-            <a:ext cx="5202936" cy="274320"/>
-          </a:xfrm>
-          <a:prstGeom prst="rect">
-            <a:avLst/>
-          </a:prstGeom>
-          <a:noFill/>
-        </p:spPr>
-        <p:txBody>
-          <a:bodyPr wrap="square" anchor="t" lIns="0" rIns="0" tIns="0" bIns="0">
-            <a:spAutoFit/>
-          </a:bodyPr>
-          <a:lstStyle/>
-          <a:p>
-            <a:pPr algn="l">
-              <a:lnSpc>
-                <a:spcPct val="115000"/>
-              </a:lnSpc>
-            </a:pPr>
-            <a:r>
-              <a:rPr sz="1250" b="1" i="0">
-                <a:solidFill>
-                  <a:srgbClr val="EEF2F8"/>
-                </a:solidFill>
-                <a:latin typeface="Arial"/>
-              </a:rPr>
-              <a:t>"No separate business logic", verified</a:t>
-            </a:r>
-          </a:p>
-        </p:txBody>
-      </p:sp>
-      <p:sp>
-        <p:nvSpPr>
-          <p:cNvPr id="12" name="TextBox 11"/>
-          <p:cNvSpPr txBox="1"/>
-          <p:nvPr/>
-        </p:nvSpPr>
-        <p:spPr>
-          <a:xfrm>
-            <a:off x="6245352" y="2130552"/>
-            <a:ext cx="5202936" cy="1783080"/>
-          </a:xfrm>
-          <a:prstGeom prst="rect">
-            <a:avLst/>
-          </a:prstGeom>
-          <a:noFill/>
-        </p:spPr>
-        <p:txBody>
-          <a:bodyPr wrap="square" anchor="t" lIns="0" rIns="0" tIns="0" bIns="0">
-            <a:spAutoFit/>
-          </a:bodyPr>
-          <a:lstStyle/>
-          <a:p>
-            <a:pPr algn="l">
-              <a:lnSpc>
-                <a:spcPct val="122000"/>
-              </a:lnSpc>
-            </a:pPr>
-            <a:r>
-              <a:rPr sz="1100" b="0" i="0">
-                <a:solidFill>
-                  <a:srgbClr val="AEBBD2"/>
-                </a:solidFill>
-                <a:latin typeface="Arial"/>
-              </a:rPr>
-              <a:t>Validate and Run shell out to the real mantis CLI as a subprocess. Submitted a config with a deliberately invalid domain: got the real CLI's own "Unknown domain" error back, not a UI-side check.</a:t>
-            </a:r>
-          </a:p>
-        </p:txBody>
-      </p:sp>
-      <p:sp>
-        <p:nvSpPr>
-          <p:cNvPr id="13" name="Rounded Rectangle 12"/>
-          <p:cNvSpPr/>
-          <p:nvPr/>
-        </p:nvSpPr>
-        <p:spPr>
-          <a:xfrm>
-            <a:off x="566928" y="4160520"/>
-            <a:ext cx="11064240" cy="1600200"/>
-          </a:xfrm>
-          <a:prstGeom prst="roundRect">
-            <a:avLst>
-              <a:gd name="adj" fmla="val 7000"/>
-            </a:avLst>
-          </a:prstGeom>
-          <a:solidFill>
-            <a:srgbClr val="331E14"/>
-          </a:solidFill>
-          <a:ln w="9525">
-            <a:solidFill>
-              <a:srgbClr val="FA4616"/>
-            </a:solidFill>
-          </a:ln>
-          <a:effectLst/>
-        </p:spPr>
-        <p:style>
-          <a:lnRef idx="1">
-            <a:schemeClr val="accent1"/>
-          </a:lnRef>
-          <a:fillRef idx="3">
-            <a:schemeClr val="accent1"/>
-          </a:fillRef>
-          <a:effectRef idx="2">
-            <a:schemeClr val="accent1"/>
-          </a:effectRef>
-          <a:fontRef idx="minor">
-            <a:schemeClr val="lt1"/>
-          </a:fontRef>
-        </p:style>
-        <p:txBody>
-          <a:bodyPr rtlCol="0" anchor="ctr"/>
-          <a:lstStyle/>
-          <a:p>
-            <a:pPr algn="ctr"/>
-          </a:p>
-        </p:txBody>
-      </p:sp>
-      <p:sp>
-        <p:nvSpPr>
-          <p:cNvPr id="14" name="TextBox 13"/>
-          <p:cNvSpPr txBox="1"/>
-          <p:nvPr/>
-        </p:nvSpPr>
-        <p:spPr>
-          <a:xfrm>
-            <a:off x="731520" y="4279392"/>
-            <a:ext cx="10735056" cy="274320"/>
-          </a:xfrm>
-          <a:prstGeom prst="rect">
-            <a:avLst/>
-          </a:prstGeom>
-          <a:noFill/>
-        </p:spPr>
-        <p:txBody>
-          <a:bodyPr wrap="square" anchor="t" lIns="0" rIns="0" tIns="0" bIns="0">
-            <a:spAutoFit/>
-          </a:bodyPr>
-          <a:lstStyle/>
-          <a:p>
-            <a:pPr algn="l">
-              <a:lnSpc>
-                <a:spcPct val="115000"/>
-              </a:lnSpc>
-            </a:pPr>
-            <a:r>
-              <a:rPr sz="1250" b="1" i="0">
-                <a:solidFill>
-                  <a:srgbClr val="FF8A5C"/>
-                </a:solidFill>
-                <a:latin typeface="Arial"/>
-              </a:rPr>
-              <a:t>Confirmed as a real running server</a:t>
-            </a:r>
-          </a:p>
-        </p:txBody>
-      </p:sp>
-      <p:sp>
-        <p:nvSpPr>
-          <p:cNvPr id="15" name="TextBox 14"/>
-          <p:cNvSpPr txBox="1"/>
-          <p:nvPr/>
-        </p:nvSpPr>
-        <p:spPr>
-          <a:xfrm>
-            <a:off x="731520" y="4599432"/>
-            <a:ext cx="10735056" cy="1051560"/>
-          </a:xfrm>
-          <a:prstGeom prst="rect">
-            <a:avLst/>
-          </a:prstGeom>
-          <a:noFill/>
-        </p:spPr>
-        <p:txBody>
-          <a:bodyPr wrap="square" anchor="t" lIns="0" rIns="0" tIns="0" bIns="0">
-            <a:spAutoFit/>
-          </a:bodyPr>
-          <a:lstStyle/>
-          <a:p>
-            <a:pPr algn="l">
-              <a:lnSpc>
-                <a:spcPct val="122000"/>
-              </a:lnSpc>
-            </a:pPr>
-            <a:r>
-              <a:rPr sz="1150" b="0" i="0">
-                <a:solidFill>
-                  <a:srgbClr val="EEF2F8"/>
-                </a:solidFill>
-                <a:latin typeface="Arial"/>
-              </a:rPr>
-              <a:t>Launched via mantis --ui and queried over real HTTP, not just an in-process test client: correctly reported the live inventory (32 agents, 22 tools) and every existing run artifact (27 runs) at the time of this check.</a:t>
-            </a:r>
-          </a:p>
-        </p:txBody>
-      </p:sp>
-      <p:cxnSp>
-        <p:nvCxnSpPr>
-          <p:cNvPr id="16" name="Connector 15"/>
-          <p:cNvCxnSpPr/>
-          <p:nvPr/>
-        </p:nvCxnSpPr>
-        <p:spPr>
-          <a:xfrm>
-            <a:off x="566928" y="6382512"/>
-            <a:ext cx="2377440" cy="0"/>
-          </a:xfrm>
-          <a:prstGeom prst="line">
-            <a:avLst/>
-          </a:prstGeom>
-          <a:ln w="9525">
-            <a:solidFill>
-              <a:srgbClr val="7E8FAE"/>
-            </a:solidFill>
-          </a:ln>
-        </p:spPr>
-        <p:style>
-          <a:lnRef idx="2">
-            <a:schemeClr val="accent1"/>
-          </a:lnRef>
-          <a:fillRef idx="0">
-            <a:schemeClr val="accent1"/>
-          </a:fillRef>
-          <a:effectRef idx="1">
-            <a:schemeClr val="accent1"/>
-          </a:effectRef>
-          <a:fontRef idx="minor">
-            <a:schemeClr val="tx1"/>
-          </a:fontRef>
-        </p:style>
-      </p:cxnSp>
-      <p:cxnSp>
-        <p:nvCxnSpPr>
-          <p:cNvPr id="17" name="Connector 16"/>
-          <p:cNvCxnSpPr/>
-          <p:nvPr/>
-        </p:nvCxnSpPr>
-        <p:spPr>
-          <a:xfrm>
-            <a:off x="9326880" y="6382512"/>
-            <a:ext cx="2286000" cy="0"/>
-          </a:xfrm>
-          <a:prstGeom prst="line">
-            <a:avLst/>
-          </a:prstGeom>
-          <a:ln w="9525">
-            <a:solidFill>
-              <a:srgbClr val="7E8FAE"/>
-            </a:solidFill>
-          </a:ln>
-        </p:spPr>
-        <p:style>
-          <a:lnRef idx="2">
-            <a:schemeClr val="accent1"/>
-          </a:lnRef>
-          <a:fillRef idx="0">
-            <a:schemeClr val="accent1"/>
-          </a:fillRef>
-          <a:effectRef idx="1">
-            <a:schemeClr val="accent1"/>
-          </a:effectRef>
-          <a:fontRef idx="minor">
-            <a:schemeClr val="tx1"/>
-          </a:fontRef>
-        </p:style>
-      </p:cxnSp>
-      <p:sp>
-        <p:nvSpPr>
-          <p:cNvPr id="18" name="TextBox 17"/>
-          <p:cNvSpPr txBox="1"/>
-          <p:nvPr/>
-        </p:nvSpPr>
-        <p:spPr>
-          <a:xfrm>
-            <a:off x="3017520" y="6281928"/>
-            <a:ext cx="6217920" cy="256032"/>
-          </a:xfrm>
-          <a:prstGeom prst="rect">
-            <a:avLst/>
-          </a:prstGeom>
-          <a:noFill/>
-        </p:spPr>
-        <p:txBody>
-          <a:bodyPr wrap="square" anchor="t" lIns="0" rIns="0" tIns="0" bIns="0">
-            <a:spAutoFit/>
-          </a:bodyPr>
-          <a:lstStyle/>
-          <a:p>
-            <a:pPr algn="ctr">
-              <a:lnSpc>
-                <a:spcPct val="115000"/>
-              </a:lnSpc>
-            </a:pPr>
-            <a:r>
-              <a:rPr sz="800" b="0" i="0">
-                <a:solidFill>
-                  <a:srgbClr val="7E8FAE"/>
-                </a:solidFill>
-                <a:latin typeface="Consolas"/>
-              </a:rPr>
-              <a:t>MANTIS EXTENDED — POST-PAPER EXTENSIONS</a:t>
-            </a:r>
-          </a:p>
-        </p:txBody>
-      </p:sp>
-      <p:sp>
-        <p:nvSpPr>
-          <p:cNvPr id="19" name="TextBox 18"/>
-          <p:cNvSpPr txBox="1"/>
-          <p:nvPr/>
-        </p:nvSpPr>
-        <p:spPr>
-          <a:xfrm>
-            <a:off x="11430000" y="6281928"/>
-            <a:ext cx="548640" cy="256032"/>
-          </a:xfrm>
-          <a:prstGeom prst="rect">
-            <a:avLst/>
-          </a:prstGeom>
-          <a:noFill/>
-        </p:spPr>
-        <p:txBody>
-          <a:bodyPr wrap="square" anchor="t" lIns="0" rIns="0" tIns="0" bIns="0">
-            <a:spAutoFit/>
-          </a:bodyPr>
-          <a:lstStyle/>
-          <a:p>
-            <a:pPr algn="r">
-              <a:lnSpc>
-                <a:spcPct val="115000"/>
-              </a:lnSpc>
-            </a:pPr>
-            <a:r>
-              <a:rPr sz="900" b="1" i="0">
-                <a:solidFill>
-                  <a:srgbClr val="AEBBD2"/>
-                </a:solidFill>
-                <a:latin typeface="Consolas"/>
-              </a:rPr>
-              <a:t>8</a:t>
-            </a:r>
-          </a:p>
-        </p:txBody>
-      </p:sp>
-    </p:spTree>
-  </p:cSld>
-  <p:clrMapOvr>
-    <a:masterClrMapping/>
-  </p:clrMapOvr>
-</p:sld>
-</file>
-
-<file path=ppt/slides/slide9.xml><?xml version="1.0" encoding="utf-8"?>
-<p:sld xmlns:a="http://schemas.openxmlformats.org/drawingml/2006/main" xmlns:p="http://schemas.openxmlformats.org/presentationml/2006/main" xmlns:r="http://schemas.openxmlformats.org/officeDocument/2006/relationships">
-  <p:cSld>
-    <p:spTree>
-      <p:nvGrpSpPr>
-        <p:cNvPr id="1" name=""/>
-        <p:cNvGrpSpPr/>
-        <p:nvPr/>
-      </p:nvGrpSpPr>
-      <p:grpSpPr/>
-      <p:sp>
-        <p:nvSpPr>
-          <p:cNvPr id="2" name="Rectangle 1"/>
-          <p:cNvSpPr/>
-          <p:nvPr/>
-        </p:nvSpPr>
-        <p:spPr>
-          <a:xfrm>
-            <a:off x="0" y="0"/>
-            <a:ext cx="12191695" cy="6858000"/>
-          </a:xfrm>
-          <a:prstGeom prst="rect">
-            <a:avLst/>
-          </a:prstGeom>
-          <a:solidFill>
-            <a:srgbClr val="071022"/>
-          </a:solidFill>
-          <a:ln>
-            <a:noFill/>
-          </a:ln>
-          <a:effectLst/>
-        </p:spPr>
-        <p:style>
-          <a:lnRef idx="1">
-            <a:schemeClr val="accent1"/>
-          </a:lnRef>
-          <a:fillRef idx="3">
-            <a:schemeClr val="accent1"/>
-          </a:fillRef>
-          <a:effectRef idx="2">
-            <a:schemeClr val="accent1"/>
-          </a:effectRef>
-          <a:fontRef idx="minor">
-            <a:schemeClr val="lt1"/>
-          </a:fontRef>
-        </p:style>
-        <p:txBody>
-          <a:bodyPr rtlCol="0" anchor="ctr"/>
-          <a:lstStyle/>
-          <a:p>
-            <a:pPr algn="ctr"/>
-          </a:p>
-        </p:txBody>
-      </p:sp>
-      <p:sp>
-        <p:nvSpPr>
-          <p:cNvPr id="3" name="Rounded Rectangle 2"/>
-          <p:cNvSpPr/>
-          <p:nvPr/>
-        </p:nvSpPr>
-        <p:spPr>
-          <a:xfrm>
-            <a:off x="566928" y="292608"/>
-            <a:ext cx="310896" cy="310896"/>
-          </a:xfrm>
-          <a:prstGeom prst="roundRect">
-            <a:avLst>
-              <a:gd name="adj" fmla="val 16000"/>
-            </a:avLst>
-          </a:prstGeom>
-          <a:solidFill>
-            <a:srgbClr val="071022"/>
-          </a:solidFill>
-          <a:ln w="15875">
-            <a:solidFill>
-              <a:srgbClr val="EEF2F8"/>
-            </a:solidFill>
-          </a:ln>
-          <a:effectLst/>
-        </p:spPr>
-        <p:style>
-          <a:lnRef idx="1">
-            <a:schemeClr val="accent1"/>
-          </a:lnRef>
-          <a:fillRef idx="3">
-            <a:schemeClr val="accent1"/>
-          </a:fillRef>
-          <a:effectRef idx="2">
-            <a:schemeClr val="accent1"/>
-          </a:effectRef>
-          <a:fontRef idx="minor">
-            <a:schemeClr val="lt1"/>
-          </a:fontRef>
-        </p:style>
-        <p:txBody>
-          <a:bodyPr rtlCol="0" anchor="ctr" lIns="0" rIns="0" tIns="0" bIns="0"/>
-          <a:lstStyle/>
-          <a:p>
-            <a:pPr algn="ctr"/>
-            <a:r>
-              <a:rPr sz="1200" b="1">
-                <a:solidFill>
-                  <a:srgbClr val="EEF2F8"/>
-                </a:solidFill>
-                <a:latin typeface="Arial"/>
-              </a:rPr>
-              <a:t>UF</a:t>
-            </a:r>
-          </a:p>
-        </p:txBody>
-      </p:sp>
-      <p:sp>
-        <p:nvSpPr>
-          <p:cNvPr id="4" name="TextBox 3"/>
-          <p:cNvSpPr txBox="1"/>
-          <p:nvPr/>
-        </p:nvSpPr>
-        <p:spPr>
-          <a:xfrm>
-            <a:off x="969264" y="256032"/>
-            <a:ext cx="3291840" cy="384048"/>
-          </a:xfrm>
-          <a:prstGeom prst="rect">
-            <a:avLst/>
-          </a:prstGeom>
-          <a:noFill/>
-        </p:spPr>
-        <p:txBody>
-          <a:bodyPr wrap="square" anchor="t" lIns="0" rIns="0" tIns="0" bIns="0">
-            <a:spAutoFit/>
-          </a:bodyPr>
-          <a:lstStyle/>
-          <a:p>
-            <a:pPr algn="l">
-              <a:lnSpc>
-                <a:spcPct val="100000"/>
-              </a:lnSpc>
-              <a:spcAft>
-                <a:spcPts val="0"/>
-              </a:spcAft>
-            </a:pPr>
-            <a:r>
-              <a:rPr sz="1050" b="1" i="0">
-                <a:solidFill>
-                  <a:srgbClr val="EEF2F8"/>
-                </a:solidFill>
-                <a:latin typeface="Arial"/>
-              </a:rPr>
-              <a:t>Herbert Wertheim</a:t>
-            </a:r>
-          </a:p>
-          <a:p>
-            <a:pPr algn="l">
-              <a:lnSpc>
-                <a:spcPct val="100000"/>
-              </a:lnSpc>
-              <a:spcAft>
-                <a:spcPts val="0"/>
-              </a:spcAft>
-            </a:pPr>
-            <a:r>
-              <a:rPr sz="900" b="0" i="1">
-                <a:solidFill>
-                  <a:srgbClr val="AEBBD2"/>
-                </a:solidFill>
-                <a:latin typeface="Georgia"/>
-              </a:rPr>
-              <a:t>College of Engineering</a:t>
-            </a:r>
-          </a:p>
-        </p:txBody>
-      </p:sp>
-      <p:sp>
-        <p:nvSpPr>
-          <p:cNvPr id="5" name="TextBox 4"/>
-          <p:cNvSpPr txBox="1"/>
-          <p:nvPr/>
-        </p:nvSpPr>
-        <p:spPr>
-          <a:xfrm>
-            <a:off x="566928" y="896112"/>
-            <a:ext cx="8229600" cy="274320"/>
-          </a:xfrm>
-          <a:prstGeom prst="rect">
-            <a:avLst/>
-          </a:prstGeom>
-          <a:noFill/>
-        </p:spPr>
-        <p:txBody>
-          <a:bodyPr wrap="square" anchor="t" lIns="0" rIns="0" tIns="0" bIns="0">
-            <a:spAutoFit/>
-          </a:bodyPr>
-          <a:lstStyle/>
-          <a:p>
-            <a:pPr algn="l">
-              <a:lnSpc>
-                <a:spcPct val="115000"/>
-              </a:lnSpc>
-            </a:pPr>
-            <a:r>
-              <a:rPr sz="1100" b="1" i="0">
-                <a:solidFill>
-                  <a:srgbClr val="FF8A5C"/>
-                </a:solidFill>
-                <a:latin typeface="Consolas"/>
-              </a:rPr>
-              <a:t>EVALUATION SUMMARY</a:t>
-            </a:r>
-          </a:p>
-        </p:txBody>
-      </p:sp>
-      <p:sp>
-        <p:nvSpPr>
-          <p:cNvPr id="6" name="TextBox 5"/>
-          <p:cNvSpPr txBox="1"/>
-          <p:nvPr/>
-        </p:nvSpPr>
-        <p:spPr>
-          <a:xfrm>
-            <a:off x="566928" y="1115568"/>
-            <a:ext cx="10607040" cy="1188720"/>
-          </a:xfrm>
-          <a:prstGeom prst="rect">
-            <a:avLst/>
-          </a:prstGeom>
-          <a:noFill/>
-        </p:spPr>
-        <p:txBody>
-          <a:bodyPr wrap="square" anchor="t" lIns="0" rIns="0" tIns="0" bIns="0">
-            <a:spAutoFit/>
-          </a:bodyPr>
-          <a:lstStyle/>
-          <a:p>
-            <a:pPr algn="l">
-              <a:lnSpc>
-                <a:spcPct val="104000"/>
-              </a:lnSpc>
-            </a:pPr>
-            <a:r>
-              <a:rPr sz="2200" b="1" i="0">
-                <a:solidFill>
-                  <a:srgbClr val="EEF2F8"/>
-                </a:solidFill>
-                <a:latin typeface="Arial Black"/>
-              </a:rPr>
-              <a:t>147 tests, all against real data — every extension live-verified</a:t>
+              <a:t>139 tests, all against real data — every extension live-verified</a:t>
             </a:r>
           </a:p>
         </p:txBody>
@@ -11416,8 +9044,8 @@
           <p:nvPr/>
         </p:nvGraphicFramePr>
         <p:xfrm>
-          <a:off x="566928" y="1645920"/>
-          <a:ext cx="11064239" cy="3429000"/>
+          <a:off x="566928" y="1691640"/>
+          <a:ext cx="11064239" cy="2880360"/>
         </p:xfrm>
         <a:graphic>
           <a:graphicData uri="http://schemas.openxmlformats.org/drawingml/2006/table">
@@ -11430,7 +9058,7 @@
                 <a:gridCol w="979136"/>
                 <a:gridCol w="7833090"/>
               </a:tblGrid>
-              <a:tr h="489857">
+              <a:tr h="480060">
                 <a:tc>
                   <a:txBody>
                     <a:bodyPr/>
@@ -11498,7 +9126,7 @@
                   </a:tcPr>
                 </a:tc>
               </a:tr>
-              <a:tr h="489857">
+              <a:tr h="480060">
                 <a:tc>
                   <a:txBody>
                     <a:bodyPr wrap="square"/>
@@ -11510,7 +9138,7 @@
                         </a:lnSpc>
                       </a:pPr>
                       <a:r>
-                        <a:rPr sz="1000" b="1">
+                        <a:rPr sz="1100" b="1">
                           <a:solidFill>
                             <a:srgbClr val="EEF2F8"/>
                           </a:solidFill>
@@ -11537,7 +9165,7 @@
                         </a:lnSpc>
                       </a:pPr>
                       <a:r>
-                        <a:rPr sz="950" b="0">
+                        <a:rPr sz="1050" b="0">
                           <a:solidFill>
                             <a:srgbClr val="AEBBD2"/>
                           </a:solidFill>
@@ -11564,7 +9192,7 @@
                         </a:lnSpc>
                       </a:pPr>
                       <a:r>
-                        <a:rPr sz="950" b="0">
+                        <a:rPr sz="1050" b="0">
                           <a:solidFill>
                             <a:srgbClr val="AEBBD2"/>
                           </a:solidFill>
@@ -11581,7 +9209,7 @@
                   </a:tcPr>
                 </a:tc>
               </a:tr>
-              <a:tr h="489857">
+              <a:tr h="480060">
                 <a:tc>
                   <a:txBody>
                     <a:bodyPr wrap="square"/>
@@ -11593,7 +9221,7 @@
                         </a:lnSpc>
                       </a:pPr>
                       <a:r>
-                        <a:rPr sz="1000" b="1">
+                        <a:rPr sz="1100" b="1">
                           <a:solidFill>
                             <a:srgbClr val="EEF2F8"/>
                           </a:solidFill>
@@ -11620,7 +9248,7 @@
                         </a:lnSpc>
                       </a:pPr>
                       <a:r>
-                        <a:rPr sz="950" b="0">
+                        <a:rPr sz="1050" b="0">
                           <a:solidFill>
                             <a:srgbClr val="AEBBD2"/>
                           </a:solidFill>
@@ -11647,7 +9275,7 @@
                         </a:lnSpc>
                       </a:pPr>
                       <a:r>
-                        <a:rPr sz="950" b="0">
+                        <a:rPr sz="1050" b="0">
                           <a:solidFill>
                             <a:srgbClr val="AEBBD2"/>
                           </a:solidFill>
@@ -11664,7 +9292,7 @@
                   </a:tcPr>
                 </a:tc>
               </a:tr>
-              <a:tr h="489857">
+              <a:tr h="480060">
                 <a:tc>
                   <a:txBody>
                     <a:bodyPr wrap="square"/>
@@ -11676,7 +9304,7 @@
                         </a:lnSpc>
                       </a:pPr>
                       <a:r>
-                        <a:rPr sz="1000" b="1">
+                        <a:rPr sz="1100" b="1">
                           <a:solidFill>
                             <a:srgbClr val="EEF2F8"/>
                           </a:solidFill>
@@ -11703,7 +9331,7 @@
                         </a:lnSpc>
                       </a:pPr>
                       <a:r>
-                        <a:rPr sz="950" b="0">
+                        <a:rPr sz="1050" b="0">
                           <a:solidFill>
                             <a:srgbClr val="AEBBD2"/>
                           </a:solidFill>
@@ -11730,7 +9358,7 @@
                         </a:lnSpc>
                       </a:pPr>
                       <a:r>
-                        <a:rPr sz="950" b="0">
+                        <a:rPr sz="1050" b="0">
                           <a:solidFill>
                             <a:srgbClr val="AEBBD2"/>
                           </a:solidFill>
@@ -11747,7 +9375,7 @@
                   </a:tcPr>
                 </a:tc>
               </a:tr>
-              <a:tr h="489857">
+              <a:tr h="480060">
                 <a:tc>
                   <a:txBody>
                     <a:bodyPr wrap="square"/>
@@ -11759,90 +9387,7 @@
                         </a:lnSpc>
                       </a:pPr>
                       <a:r>
-                        <a:rPr sz="1000" b="1">
-                          <a:solidFill>
-                            <a:srgbClr val="EEF2F8"/>
-                          </a:solidFill>
-                          <a:latin typeface="Arial"/>
-                        </a:rPr>
-                        <a:t>Zero Trust</a:t>
-                      </a:r>
-                    </a:p>
-                  </a:txBody>
-                  <a:tcPr marL="82296" marR="82296" marT="54864" marB="54864" anchor="ctr">
-                    <a:solidFill>
-                      <a:srgbClr val="14274A"/>
-                    </a:solidFill>
-                  </a:tcPr>
-                </a:tc>
-                <a:tc>
-                  <a:txBody>
-                    <a:bodyPr wrap="square"/>
-                    <a:lstStyle/>
-                    <a:p>
-                      <a:pPr>
-                        <a:lnSpc>
-                          <a:spcPct val="108000"/>
-                        </a:lnSpc>
-                      </a:pPr>
-                      <a:r>
-                        <a:rPr sz="950" b="0">
-                          <a:solidFill>
-                            <a:srgbClr val="AEBBD2"/>
-                          </a:solidFill>
-                          <a:latin typeface="Arial"/>
-                        </a:rPr>
-                        <a:t>8</a:t>
-                      </a:r>
-                    </a:p>
-                  </a:txBody>
-                  <a:tcPr marL="82296" marR="82296" marT="54864" marB="54864" anchor="ctr">
-                    <a:solidFill>
-                      <a:srgbClr val="14274A"/>
-                    </a:solidFill>
-                  </a:tcPr>
-                </a:tc>
-                <a:tc>
-                  <a:txBody>
-                    <a:bodyPr wrap="square"/>
-                    <a:lstStyle/>
-                    <a:p>
-                      <a:pPr>
-                        <a:lnSpc>
-                          <a:spcPct val="108000"/>
-                        </a:lnSpc>
-                      </a:pPr>
-                      <a:r>
-                        <a:rPr sz="950" b="0">
-                          <a:solidFill>
-                            <a:srgbClr val="AEBBD2"/>
-                          </a:solidFill>
-                          <a:latin typeface="Arial"/>
-                        </a:rPr>
-                        <a:t>770/770 (agent, tool) pairs correctly enforced; 5/5 live trials zero false-positive denials; two real defects surfaced and fixed.</a:t>
-                      </a:r>
-                    </a:p>
-                  </a:txBody>
-                  <a:tcPr marL="82296" marR="82296" marT="54864" marB="54864" anchor="ctr">
-                    <a:solidFill>
-                      <a:srgbClr val="14274A"/>
-                    </a:solidFill>
-                  </a:tcPr>
-                </a:tc>
-              </a:tr>
-              <a:tr h="489857">
-                <a:tc>
-                  <a:txBody>
-                    <a:bodyPr wrap="square"/>
-                    <a:lstStyle/>
-                    <a:p>
-                      <a:pPr>
-                        <a:lnSpc>
-                          <a:spcPct val="108000"/>
-                        </a:lnSpc>
-                      </a:pPr>
-                      <a:r>
-                        <a:rPr sz="1000" b="1">
+                        <a:rPr sz="1100" b="1">
                           <a:solidFill>
                             <a:srgbClr val="EEF2F8"/>
                           </a:solidFill>
@@ -11869,7 +9414,7 @@
                         </a:lnSpc>
                       </a:pPr>
                       <a:r>
-                        <a:rPr sz="950" b="0">
+                        <a:rPr sz="1050" b="0">
                           <a:solidFill>
                             <a:srgbClr val="AEBBD2"/>
                           </a:solidFill>
@@ -11896,7 +9441,7 @@
                         </a:lnSpc>
                       </a:pPr>
                       <a:r>
-                        <a:rPr sz="950" b="0">
+                        <a:rPr sz="1050" b="0">
                           <a:solidFill>
                             <a:srgbClr val="AEBBD2"/>
                           </a:solidFill>
@@ -11913,7 +9458,7 @@
                   </a:tcPr>
                 </a:tc>
               </a:tr>
-              <a:tr h="489858">
+              <a:tr h="480060">
                 <a:tc>
                   <a:txBody>
                     <a:bodyPr wrap="square"/>
@@ -11925,7 +9470,7 @@
                         </a:lnSpc>
                       </a:pPr>
                       <a:r>
-                        <a:rPr sz="1000" b="1">
+                        <a:rPr sz="1100" b="1">
                           <a:solidFill>
                             <a:srgbClr val="EEF2F8"/>
                           </a:solidFill>
@@ -11952,7 +9497,7 @@
                         </a:lnSpc>
                       </a:pPr>
                       <a:r>
-                        <a:rPr sz="950" b="0">
+                        <a:rPr sz="1050" b="0">
                           <a:solidFill>
                             <a:srgbClr val="AEBBD2"/>
                           </a:solidFill>
@@ -11979,7 +9524,7 @@
                         </a:lnSpc>
                       </a:pPr>
                       <a:r>
-                        <a:rPr sz="950" b="0">
+                        <a:rPr sz="1050" b="0">
                           <a:solidFill>
                             <a:srgbClr val="AEBBD2"/>
                           </a:solidFill>
@@ -12008,7 +9553,7 @@
         </p:nvSpPr>
         <p:spPr>
           <a:xfrm>
-            <a:off x="566928" y="5166360"/>
+            <a:off x="566928" y="4892040"/>
             <a:ext cx="3566160" cy="1051560"/>
           </a:xfrm>
           <a:prstGeom prst="roundRect">
@@ -12056,7 +9601,7 @@
         </p:nvSpPr>
         <p:spPr>
           <a:xfrm>
-            <a:off x="694944" y="5257800"/>
+            <a:off x="694944" y="4983480"/>
             <a:ext cx="3310128" cy="457200"/>
           </a:xfrm>
           <a:prstGeom prst="rect">
@@ -12082,7 +9627,7 @@
                 </a:solidFill>
                 <a:latin typeface="Consolas"/>
               </a:rPr>
-              <a:t>147</a:t>
+              <a:t>139</a:t>
             </a:r>
           </a:p>
         </p:txBody>
@@ -12095,7 +9640,7 @@
         </p:nvSpPr>
         <p:spPr>
           <a:xfrm>
-            <a:off x="694944" y="5715000"/>
+            <a:off x="694944" y="5440680"/>
             <a:ext cx="3310128" cy="429768"/>
           </a:xfrm>
           <a:prstGeom prst="rect">
@@ -12134,7 +9679,7 @@
         </p:nvSpPr>
         <p:spPr>
           <a:xfrm>
-            <a:off x="4315967" y="5166360"/>
+            <a:off x="4315967" y="4892040"/>
             <a:ext cx="3566160" cy="1051560"/>
           </a:xfrm>
           <a:prstGeom prst="roundRect">
@@ -12182,7 +9727,7 @@
         </p:nvSpPr>
         <p:spPr>
           <a:xfrm>
-            <a:off x="4443983" y="5257800"/>
+            <a:off x="4443983" y="4983480"/>
             <a:ext cx="3310128" cy="457200"/>
           </a:xfrm>
           <a:prstGeom prst="rect">
@@ -12221,7 +9766,7 @@
         </p:nvSpPr>
         <p:spPr>
           <a:xfrm>
-            <a:off x="4443983" y="5715000"/>
+            <a:off x="4443983" y="5440680"/>
             <a:ext cx="3310128" cy="429768"/>
           </a:xfrm>
           <a:prstGeom prst="rect">
@@ -12260,7 +9805,7 @@
         </p:nvSpPr>
         <p:spPr>
           <a:xfrm>
-            <a:off x="8065007" y="5166360"/>
+            <a:off x="8065007" y="4892040"/>
             <a:ext cx="3566160" cy="1051560"/>
           </a:xfrm>
           <a:prstGeom prst="roundRect">
@@ -12308,7 +9853,7 @@
         </p:nvSpPr>
         <p:spPr>
           <a:xfrm>
-            <a:off x="8193023" y="5257800"/>
+            <a:off x="8193023" y="4983480"/>
             <a:ext cx="3310128" cy="457200"/>
           </a:xfrm>
           <a:prstGeom prst="rect">
@@ -12334,7 +9879,7 @@
                 </a:solidFill>
                 <a:latin typeface="Consolas"/>
               </a:rPr>
-              <a:t>3</a:t>
+              <a:t>1</a:t>
             </a:r>
           </a:p>
         </p:txBody>
@@ -12347,7 +9892,7 @@
         </p:nvSpPr>
         <p:spPr>
           <a:xfrm>
-            <a:off x="8193023" y="5715000"/>
+            <a:off x="8193023" y="5440680"/>
             <a:ext cx="3310128" cy="429768"/>
           </a:xfrm>
           <a:prstGeom prst="rect">
@@ -12373,7 +9918,7 @@
                 </a:solidFill>
                 <a:latin typeface="Arial"/>
               </a:rPr>
-              <a:t>real defects found and fixed while building these extensions</a:t>
+              <a:t>real defect found and fixed while building these extensions</a:t>
             </a:r>
           </a:p>
         </p:txBody>
@@ -12521,7 +10066,507 @@
                 </a:solidFill>
                 <a:latin typeface="Consolas"/>
               </a:rPr>
-              <a:t>9</a:t>
+              <a:t>7</a:t>
+            </a:r>
+          </a:p>
+        </p:txBody>
+      </p:sp>
+    </p:spTree>
+  </p:cSld>
+  <p:clrMapOvr>
+    <a:masterClrMapping/>
+  </p:clrMapOvr>
+</p:sld>
+</file>
+
+<file path=ppt/slides/slide8.xml><?xml version="1.0" encoding="utf-8"?>
+<p:sld xmlns:a="http://schemas.openxmlformats.org/drawingml/2006/main" xmlns:p="http://schemas.openxmlformats.org/presentationml/2006/main" xmlns:r="http://schemas.openxmlformats.org/officeDocument/2006/relationships">
+  <p:cSld>
+    <p:spTree>
+      <p:nvGrpSpPr>
+        <p:cNvPr id="1" name=""/>
+        <p:cNvGrpSpPr/>
+        <p:nvPr/>
+      </p:nvGrpSpPr>
+      <p:grpSpPr/>
+      <p:sp>
+        <p:nvSpPr>
+          <p:cNvPr id="2" name="Rectangle 1"/>
+          <p:cNvSpPr/>
+          <p:nvPr/>
+        </p:nvSpPr>
+        <p:spPr>
+          <a:xfrm>
+            <a:off x="0" y="0"/>
+            <a:ext cx="12191695" cy="6858000"/>
+          </a:xfrm>
+          <a:prstGeom prst="rect">
+            <a:avLst/>
+          </a:prstGeom>
+          <a:solidFill>
+            <a:srgbClr val="071022"/>
+          </a:solidFill>
+          <a:ln>
+            <a:noFill/>
+          </a:ln>
+          <a:effectLst/>
+        </p:spPr>
+        <p:style>
+          <a:lnRef idx="1">
+            <a:schemeClr val="accent1"/>
+          </a:lnRef>
+          <a:fillRef idx="3">
+            <a:schemeClr val="accent1"/>
+          </a:fillRef>
+          <a:effectRef idx="2">
+            <a:schemeClr val="accent1"/>
+          </a:effectRef>
+          <a:fontRef idx="minor">
+            <a:schemeClr val="lt1"/>
+          </a:fontRef>
+        </p:style>
+        <p:txBody>
+          <a:bodyPr rtlCol="0" anchor="ctr"/>
+          <a:lstStyle/>
+          <a:p>
+            <a:pPr algn="ctr"/>
+          </a:p>
+        </p:txBody>
+      </p:sp>
+      <p:sp>
+        <p:nvSpPr>
+          <p:cNvPr id="3" name="Rounded Rectangle 2"/>
+          <p:cNvSpPr/>
+          <p:nvPr/>
+        </p:nvSpPr>
+        <p:spPr>
+          <a:xfrm>
+            <a:off x="566928" y="292608"/>
+            <a:ext cx="310896" cy="310896"/>
+          </a:xfrm>
+          <a:prstGeom prst="roundRect">
+            <a:avLst>
+              <a:gd name="adj" fmla="val 16000"/>
+            </a:avLst>
+          </a:prstGeom>
+          <a:solidFill>
+            <a:srgbClr val="071022"/>
+          </a:solidFill>
+          <a:ln w="15875">
+            <a:solidFill>
+              <a:srgbClr val="EEF2F8"/>
+            </a:solidFill>
+          </a:ln>
+          <a:effectLst/>
+        </p:spPr>
+        <p:style>
+          <a:lnRef idx="1">
+            <a:schemeClr val="accent1"/>
+          </a:lnRef>
+          <a:fillRef idx="3">
+            <a:schemeClr val="accent1"/>
+          </a:fillRef>
+          <a:effectRef idx="2">
+            <a:schemeClr val="accent1"/>
+          </a:effectRef>
+          <a:fontRef idx="minor">
+            <a:schemeClr val="lt1"/>
+          </a:fontRef>
+        </p:style>
+        <p:txBody>
+          <a:bodyPr rtlCol="0" anchor="ctr" lIns="0" rIns="0" tIns="0" bIns="0"/>
+          <a:lstStyle/>
+          <a:p>
+            <a:pPr algn="ctr"/>
+            <a:r>
+              <a:rPr sz="1200" b="1">
+                <a:solidFill>
+                  <a:srgbClr val="EEF2F8"/>
+                </a:solidFill>
+                <a:latin typeface="Arial"/>
+              </a:rPr>
+              <a:t>UF</a:t>
+            </a:r>
+          </a:p>
+        </p:txBody>
+      </p:sp>
+      <p:sp>
+        <p:nvSpPr>
+          <p:cNvPr id="4" name="TextBox 3"/>
+          <p:cNvSpPr txBox="1"/>
+          <p:nvPr/>
+        </p:nvSpPr>
+        <p:spPr>
+          <a:xfrm>
+            <a:off x="969264" y="256032"/>
+            <a:ext cx="3291840" cy="384048"/>
+          </a:xfrm>
+          <a:prstGeom prst="rect">
+            <a:avLst/>
+          </a:prstGeom>
+          <a:noFill/>
+        </p:spPr>
+        <p:txBody>
+          <a:bodyPr wrap="square" anchor="t" lIns="0" rIns="0" tIns="0" bIns="0">
+            <a:spAutoFit/>
+          </a:bodyPr>
+          <a:lstStyle/>
+          <a:p>
+            <a:pPr algn="l">
+              <a:lnSpc>
+                <a:spcPct val="100000"/>
+              </a:lnSpc>
+              <a:spcAft>
+                <a:spcPts val="0"/>
+              </a:spcAft>
+            </a:pPr>
+            <a:r>
+              <a:rPr sz="1050" b="1" i="0">
+                <a:solidFill>
+                  <a:srgbClr val="EEF2F8"/>
+                </a:solidFill>
+                <a:latin typeface="Arial"/>
+              </a:rPr>
+              <a:t>Herbert Wertheim</a:t>
+            </a:r>
+          </a:p>
+          <a:p>
+            <a:pPr algn="l">
+              <a:lnSpc>
+                <a:spcPct val="100000"/>
+              </a:lnSpc>
+              <a:spcAft>
+                <a:spcPts val="0"/>
+              </a:spcAft>
+            </a:pPr>
+            <a:r>
+              <a:rPr sz="900" b="0" i="1">
+                <a:solidFill>
+                  <a:srgbClr val="AEBBD2"/>
+                </a:solidFill>
+                <a:latin typeface="Georgia"/>
+              </a:rPr>
+              <a:t>College of Engineering</a:t>
+            </a:r>
+          </a:p>
+        </p:txBody>
+      </p:sp>
+      <p:sp>
+        <p:nvSpPr>
+          <p:cNvPr id="5" name="TextBox 4"/>
+          <p:cNvSpPr txBox="1"/>
+          <p:nvPr/>
+        </p:nvSpPr>
+        <p:spPr>
+          <a:xfrm>
+            <a:off x="566928" y="896112"/>
+            <a:ext cx="8229600" cy="274320"/>
+          </a:xfrm>
+          <a:prstGeom prst="rect">
+            <a:avLst/>
+          </a:prstGeom>
+          <a:noFill/>
+        </p:spPr>
+        <p:txBody>
+          <a:bodyPr wrap="square" anchor="t" lIns="0" rIns="0" tIns="0" bIns="0">
+            <a:spAutoFit/>
+          </a:bodyPr>
+          <a:lstStyle/>
+          <a:p>
+            <a:pPr algn="l">
+              <a:lnSpc>
+                <a:spcPct val="115000"/>
+              </a:lnSpc>
+            </a:pPr>
+            <a:r>
+              <a:rPr sz="1100" b="1" i="0">
+                <a:solidFill>
+                  <a:srgbClr val="FF8A5C"/>
+                </a:solidFill>
+                <a:latin typeface="Consolas"/>
+              </a:rPr>
+              <a:t>THANK YOU</a:t>
+            </a:r>
+          </a:p>
+        </p:txBody>
+      </p:sp>
+      <p:sp>
+        <p:nvSpPr>
+          <p:cNvPr id="6" name="TextBox 5"/>
+          <p:cNvSpPr txBox="1"/>
+          <p:nvPr/>
+        </p:nvSpPr>
+        <p:spPr>
+          <a:xfrm>
+            <a:off x="566928" y="2788920"/>
+            <a:ext cx="10607040" cy="1188720"/>
+          </a:xfrm>
+          <a:prstGeom prst="rect">
+            <a:avLst/>
+          </a:prstGeom>
+          <a:noFill/>
+        </p:spPr>
+        <p:txBody>
+          <a:bodyPr wrap="square" anchor="t" lIns="0" rIns="0" tIns="0" bIns="0">
+            <a:spAutoFit/>
+          </a:bodyPr>
+          <a:lstStyle/>
+          <a:p>
+            <a:pPr algn="l">
+              <a:lnSpc>
+                <a:spcPct val="104000"/>
+              </a:lnSpc>
+            </a:pPr>
+            <a:r>
+              <a:rPr sz="2600" b="1" i="0">
+                <a:solidFill>
+                  <a:srgbClr val="EEF2F8"/>
+                </a:solidFill>
+                <a:latin typeface="Arial Black"/>
+              </a:rPr>
+              <a:t>Four extensions, zero core changes, real evidence for each</a:t>
+            </a:r>
+          </a:p>
+        </p:txBody>
+      </p:sp>
+      <p:sp>
+        <p:nvSpPr>
+          <p:cNvPr id="7" name="TextBox 6"/>
+          <p:cNvSpPr txBox="1"/>
+          <p:nvPr/>
+        </p:nvSpPr>
+        <p:spPr>
+          <a:xfrm>
+            <a:off x="566928" y="3611880"/>
+            <a:ext cx="9144000" cy="822960"/>
+          </a:xfrm>
+          <a:prstGeom prst="rect">
+            <a:avLst/>
+          </a:prstGeom>
+          <a:noFill/>
+        </p:spPr>
+        <p:txBody>
+          <a:bodyPr wrap="square" anchor="t" lIns="0" rIns="0" tIns="0" bIns="0">
+            <a:spAutoFit/>
+          </a:bodyPr>
+          <a:lstStyle/>
+          <a:p>
+            <a:pPr algn="l">
+              <a:lnSpc>
+                <a:spcPct val="130000"/>
+              </a:lnSpc>
+            </a:pPr>
+            <a:r>
+              <a:rPr sz="1400" b="0" i="1">
+                <a:solidFill>
+                  <a:srgbClr val="AEBBD2"/>
+                </a:solidFill>
+                <a:latin typeface="Georgia"/>
+              </a:rPr>
+              <a:t>Paper 1's interfaces held up exactly as designed. Happy to walk through any extension live,</a:t>
+            </a:r>
+          </a:p>
+          <a:p>
+            <a:pPr algn="l">
+              <a:lnSpc>
+                <a:spcPct val="130000"/>
+              </a:lnSpc>
+            </a:pPr>
+            <a:r>
+              <a:rPr sz="1400" b="0" i="1">
+                <a:solidFill>
+                  <a:srgbClr val="AEBBD2"/>
+                </a:solidFill>
+                <a:latin typeface="Georgia"/>
+              </a:rPr>
+              <a:t>or discuss the separate Zero Trust Backplane integration effort.</a:t>
+            </a:r>
+          </a:p>
+        </p:txBody>
+      </p:sp>
+      <p:sp>
+        <p:nvSpPr>
+          <p:cNvPr id="8" name="TextBox 7"/>
+          <p:cNvSpPr txBox="1"/>
+          <p:nvPr/>
+        </p:nvSpPr>
+        <p:spPr>
+          <a:xfrm>
+            <a:off x="566928" y="4526280"/>
+            <a:ext cx="7315200" cy="457200"/>
+          </a:xfrm>
+          <a:prstGeom prst="rect">
+            <a:avLst/>
+          </a:prstGeom>
+          <a:noFill/>
+        </p:spPr>
+        <p:txBody>
+          <a:bodyPr wrap="square" anchor="t" lIns="0" rIns="0" tIns="0" bIns="0">
+            <a:spAutoFit/>
+          </a:bodyPr>
+          <a:lstStyle/>
+          <a:p>
+            <a:pPr algn="l">
+              <a:lnSpc>
+                <a:spcPct val="115000"/>
+              </a:lnSpc>
+            </a:pPr>
+            <a:r>
+              <a:rPr sz="1500" b="0" i="0">
+                <a:solidFill>
+                  <a:srgbClr val="AEBBD2"/>
+                </a:solidFill>
+                <a:latin typeface="Consolas"/>
+              </a:rPr>
+              <a:t>github.com/smartsystemslab-uf/MANTIS</a:t>
+            </a:r>
+          </a:p>
+        </p:txBody>
+      </p:sp>
+      <p:cxnSp>
+        <p:nvCxnSpPr>
+          <p:cNvPr id="9" name="Connector 8"/>
+          <p:cNvCxnSpPr/>
+          <p:nvPr/>
+        </p:nvCxnSpPr>
+        <p:spPr>
+          <a:xfrm>
+            <a:off x="566928" y="6382512"/>
+            <a:ext cx="2377440" cy="0"/>
+          </a:xfrm>
+          <a:prstGeom prst="line">
+            <a:avLst/>
+          </a:prstGeom>
+          <a:ln w="9525">
+            <a:solidFill>
+              <a:srgbClr val="7E8FAE"/>
+            </a:solidFill>
+          </a:ln>
+        </p:spPr>
+        <p:style>
+          <a:lnRef idx="2">
+            <a:schemeClr val="accent1"/>
+          </a:lnRef>
+          <a:fillRef idx="0">
+            <a:schemeClr val="accent1"/>
+          </a:fillRef>
+          <a:effectRef idx="1">
+            <a:schemeClr val="accent1"/>
+          </a:effectRef>
+          <a:fontRef idx="minor">
+            <a:schemeClr val="tx1"/>
+          </a:fontRef>
+        </p:style>
+      </p:cxnSp>
+      <p:cxnSp>
+        <p:nvCxnSpPr>
+          <p:cNvPr id="10" name="Connector 9"/>
+          <p:cNvCxnSpPr/>
+          <p:nvPr/>
+        </p:nvCxnSpPr>
+        <p:spPr>
+          <a:xfrm>
+            <a:off x="9326880" y="6382512"/>
+            <a:ext cx="2286000" cy="0"/>
+          </a:xfrm>
+          <a:prstGeom prst="line">
+            <a:avLst/>
+          </a:prstGeom>
+          <a:ln w="9525">
+            <a:solidFill>
+              <a:srgbClr val="7E8FAE"/>
+            </a:solidFill>
+          </a:ln>
+        </p:spPr>
+        <p:style>
+          <a:lnRef idx="2">
+            <a:schemeClr val="accent1"/>
+          </a:lnRef>
+          <a:fillRef idx="0">
+            <a:schemeClr val="accent1"/>
+          </a:fillRef>
+          <a:effectRef idx="1">
+            <a:schemeClr val="accent1"/>
+          </a:effectRef>
+          <a:fontRef idx="minor">
+            <a:schemeClr val="tx1"/>
+          </a:fontRef>
+        </p:style>
+      </p:cxnSp>
+      <p:sp>
+        <p:nvSpPr>
+          <p:cNvPr id="11" name="TextBox 10"/>
+          <p:cNvSpPr txBox="1"/>
+          <p:nvPr/>
+        </p:nvSpPr>
+        <p:spPr>
+          <a:xfrm>
+            <a:off x="3017520" y="6281928"/>
+            <a:ext cx="6217920" cy="256032"/>
+          </a:xfrm>
+          <a:prstGeom prst="rect">
+            <a:avLst/>
+          </a:prstGeom>
+          <a:noFill/>
+        </p:spPr>
+        <p:txBody>
+          <a:bodyPr wrap="square" anchor="t" lIns="0" rIns="0" tIns="0" bIns="0">
+            <a:spAutoFit/>
+          </a:bodyPr>
+          <a:lstStyle/>
+          <a:p>
+            <a:pPr algn="ctr">
+              <a:lnSpc>
+                <a:spcPct val="115000"/>
+              </a:lnSpc>
+            </a:pPr>
+            <a:r>
+              <a:rPr sz="800" b="0" i="0">
+                <a:solidFill>
+                  <a:srgbClr val="7E8FAE"/>
+                </a:solidFill>
+                <a:latin typeface="Consolas"/>
+              </a:rPr>
+              <a:t>Leading the Charge, Charging Ahead</a:t>
+            </a:r>
+          </a:p>
+        </p:txBody>
+      </p:sp>
+      <p:sp>
+        <p:nvSpPr>
+          <p:cNvPr id="12" name="TextBox 11"/>
+          <p:cNvSpPr txBox="1"/>
+          <p:nvPr/>
+        </p:nvSpPr>
+        <p:spPr>
+          <a:xfrm>
+            <a:off x="11430000" y="6281928"/>
+            <a:ext cx="548640" cy="256032"/>
+          </a:xfrm>
+          <a:prstGeom prst="rect">
+            <a:avLst/>
+          </a:prstGeom>
+          <a:noFill/>
+        </p:spPr>
+        <p:txBody>
+          <a:bodyPr wrap="square" anchor="t" lIns="0" rIns="0" tIns="0" bIns="0">
+            <a:spAutoFit/>
+          </a:bodyPr>
+          <a:lstStyle/>
+          <a:p>
+            <a:pPr algn="r">
+              <a:lnSpc>
+                <a:spcPct val="115000"/>
+              </a:lnSpc>
+            </a:pPr>
+            <a:r>
+              <a:rPr sz="900" b="1" i="0">
+                <a:solidFill>
+                  <a:srgbClr val="AEBBD2"/>
+                </a:solidFill>
+                <a:latin typeface="Consolas"/>
+              </a:rPr>
+              <a:t>8</a:t>
             </a:r>
           </a:p>
         </p:txBody>

</xml_diff>